<commit_message>
folien: cloudhelden-logo und technologie-icons eingebunden
</commit_message>
<xml_diff>
--- a/folien/dist/00-orientierung.pptx
+++ b/folien/dist/00-orientierung.pptx
@@ -2922,9 +2922,33 @@
           <a:chExt cx="0" cy="0"/>
         </a:xfrm>
       </p:grpSpPr>
-      <p:sp>
-        <p:nvSpPr>
-          <p:cNvPr id="2" name="Shape 0"/>
+      <p:pic>
+        <p:nvPicPr>
+          <p:cNvPr id="2" name="Image 0" descr="/Users/jacobmenge/Desktop/kurs-unterlagen/folien/assets/icons/cloudhelden.png">    </p:cNvPr>
+          <p:cNvPicPr>
+            <a:picLocks noChangeAspect="1"/>
+          </p:cNvPicPr>
+          <p:nvPr/>
+        </p:nvPicPr>
+        <p:blipFill>
+          <a:blip r:embed="rId1"/>
+          <a:stretch>
+            <a:fillRect/>
+          </a:stretch>
+        </p:blipFill>
+        <p:spPr>
+          <a:xfrm>
+            <a:off x="7726680" y="365760"/>
+            <a:ext cx="868680" cy="868680"/>
+          </a:xfrm>
+          <a:prstGeom prst="rect">
+            <a:avLst/>
+          </a:prstGeom>
+        </p:spPr>
+      </p:pic>
+      <p:sp>
+        <p:nvSpPr>
+          <p:cNvPr id="3" name="Shape 0"/>
           <p:cNvSpPr/>
           <p:nvPr/>
         </p:nvSpPr>
@@ -2944,7 +2968,7 @@
       </p:sp>
       <p:sp>
         <p:nvSpPr>
-          <p:cNvPr id="3" name="Text 1"/>
+          <p:cNvPr id="4" name="Text 1"/>
           <p:cNvSpPr/>
           <p:nvPr/>
         </p:nvSpPr>
@@ -2983,7 +3007,7 @@
       </p:sp>
       <p:sp>
         <p:nvSpPr>
-          <p:cNvPr id="4" name="Text 2"/>
+          <p:cNvPr id="5" name="Text 2"/>
           <p:cNvSpPr/>
           <p:nvPr/>
         </p:nvSpPr>
@@ -3022,7 +3046,7 @@
       </p:sp>
       <p:sp>
         <p:nvSpPr>
-          <p:cNvPr id="5" name="Text 3"/>
+          <p:cNvPr id="6" name="Text 3"/>
           <p:cNvSpPr/>
           <p:nvPr/>
         </p:nvSpPr>
@@ -3061,7 +3085,7 @@
       </p:sp>
       <p:sp>
         <p:nvSpPr>
-          <p:cNvPr id="6" name="Shape 4"/>
+          <p:cNvPr id="7" name="Shape 4"/>
           <p:cNvSpPr/>
           <p:nvPr/>
         </p:nvSpPr>
@@ -3084,7 +3108,7 @@
       </p:sp>
       <p:sp>
         <p:nvSpPr>
-          <p:cNvPr id="7" name="Text 5"/>
+          <p:cNvPr id="8" name="Text 5"/>
           <p:cNvSpPr/>
           <p:nvPr/>
         </p:nvSpPr>
@@ -6106,774 +6130,62 @@
       </p:sp>
       <p:sp>
         <p:nvSpPr>
-          <p:cNvPr id="6" name="Shape 4"/>
-          <p:cNvSpPr/>
-          <p:nvPr/>
-        </p:nvSpPr>
-        <p:spPr>
-          <a:xfrm>
-            <a:off x="566928" y="1975104"/>
-            <a:ext cx="2523744" cy="1920240"/>
-          </a:xfrm>
-          <a:prstGeom prst="rect">
-            <a:avLst/>
+          <p:cNvPr id="6" name="Text 4"/>
+          <p:cNvSpPr/>
+          <p:nvPr/>
+        </p:nvSpPr>
+        <p:spPr>
+          <a:xfrm>
+            <a:off x="566928" y="1938528"/>
+            <a:ext cx="2560320" cy="256032"/>
+          </a:xfrm>
+          <a:prstGeom prst="rect">
+            <a:avLst/>
+          </a:prstGeom>
+          <a:noFill/>
+          <a:ln/>
+        </p:spPr>
+        <p:txBody>
+          <a:bodyPr wrap="square" lIns="0" tIns="0" rIns="0" bIns="0" rtlCol="0" anchor="ctr"/>
+          <a:lstStyle/>
+          <a:p>
+            <a:pPr indent="0" marL="0">
+              <a:buNone/>
+            </a:pPr>
+            <a:r>
+              <a:rPr lang="en-US" sz="1100" b="1" dirty="0">
+                <a:solidFill>
+                  <a:srgbClr val="5C6377"/>
+                </a:solidFill>
+                <a:latin typeface="Arial" pitchFamily="34" charset="0"/>
+                <a:ea typeface="Arial" pitchFamily="34" charset="-122"/>
+                <a:cs typeface="Arial" pitchFamily="34" charset="-120"/>
+              </a:rPr>
+              <a:t>Thema 1 · Planung &amp; Integration</a:t>
+            </a:r>
+            <a:endParaRPr lang="en-US" sz="1100" dirty="0"/>
+          </a:p>
+        </p:txBody>
+      </p:sp>
+      <p:sp>
+        <p:nvSpPr>
+          <p:cNvPr id="7" name="Shape 5"/>
+          <p:cNvSpPr/>
+          <p:nvPr/>
+        </p:nvSpPr>
+        <p:spPr>
+          <a:xfrm>
+            <a:off x="566928" y="2231136"/>
+            <a:ext cx="2560320" cy="384048"/>
+          </a:xfrm>
+          <a:prstGeom prst="roundRect">
+            <a:avLst>
+              <a:gd name="adj" fmla="val 11905"/>
+            </a:avLst>
           </a:prstGeom>
           <a:solidFill>
             <a:srgbClr val="F5F6FC"/>
           </a:solidFill>
-          <a:ln/>
-        </p:spPr>
-      </p:sp>
-      <p:sp>
-        <p:nvSpPr>
-          <p:cNvPr id="7" name="Shape 5"/>
-          <p:cNvSpPr/>
-          <p:nvPr/>
-        </p:nvSpPr>
-        <p:spPr>
-          <a:xfrm>
-            <a:off x="566928" y="1975104"/>
-            <a:ext cx="41148" cy="1920240"/>
-          </a:xfrm>
-          <a:prstGeom prst="rect">
-            <a:avLst/>
-          </a:prstGeom>
-          <a:solidFill>
-            <a:srgbClr val="3843AF"/>
-          </a:solidFill>
-          <a:ln/>
-        </p:spPr>
-      </p:sp>
-      <p:sp>
-        <p:nvSpPr>
-          <p:cNvPr id="8" name="Text 6"/>
-          <p:cNvSpPr/>
-          <p:nvPr/>
-        </p:nvSpPr>
-        <p:spPr>
-          <a:xfrm>
-            <a:off x="804672" y="2066544"/>
-            <a:ext cx="384048" cy="411480"/>
-          </a:xfrm>
-          <a:prstGeom prst="rect">
-            <a:avLst/>
-          </a:prstGeom>
-          <a:noFill/>
-          <a:ln/>
-        </p:spPr>
-        <p:txBody>
-          <a:bodyPr wrap="square" lIns="0" tIns="0" rIns="0" bIns="0" rtlCol="0" anchor="t"/>
-          <a:lstStyle/>
-          <a:p>
-            <a:pPr indent="0" marL="0">
-              <a:buNone/>
-            </a:pPr>
-            <a:r>
-              <a:rPr lang="en-US" sz="2000" b="1" dirty="0">
-                <a:solidFill>
-                  <a:srgbClr val="3843AF"/>
-                </a:solidFill>
-                <a:latin typeface="Courier New" pitchFamily="34" charset="0"/>
-                <a:ea typeface="Courier New" pitchFamily="34" charset="-122"/>
-                <a:cs typeface="Courier New" pitchFamily="34" charset="-120"/>
-              </a:rPr>
-              <a:t>1</a:t>
-            </a:r>
-            <a:endParaRPr lang="en-US" sz="2000" dirty="0"/>
-          </a:p>
-        </p:txBody>
-      </p:sp>
-      <p:sp>
-        <p:nvSpPr>
-          <p:cNvPr id="9" name="Text 7"/>
-          <p:cNvSpPr/>
-          <p:nvPr/>
-        </p:nvSpPr>
-        <p:spPr>
-          <a:xfrm>
-            <a:off x="1298448" y="2121408"/>
-            <a:ext cx="1627632" cy="438912"/>
-          </a:xfrm>
-          <a:prstGeom prst="rect">
-            <a:avLst/>
-          </a:prstGeom>
-          <a:noFill/>
-          <a:ln/>
-        </p:spPr>
-        <p:txBody>
-          <a:bodyPr wrap="square" lIns="0" tIns="0" rIns="0" bIns="0" rtlCol="0" anchor="t"/>
-          <a:lstStyle/>
-          <a:p>
-            <a:pPr indent="0" marL="0">
-              <a:buNone/>
-            </a:pPr>
-            <a:r>
-              <a:rPr lang="en-US" sz="1200" b="1" dirty="0">
-                <a:solidFill>
-                  <a:srgbClr val="272E52"/>
-                </a:solidFill>
-                <a:latin typeface="Arial" pitchFamily="34" charset="0"/>
-                <a:ea typeface="Arial" pitchFamily="34" charset="-122"/>
-                <a:cs typeface="Arial" pitchFamily="34" charset="-120"/>
-              </a:rPr>
-              <a:t>Planung und Integration</a:t>
-            </a:r>
-            <a:endParaRPr lang="en-US" sz="1200" dirty="0"/>
-          </a:p>
-        </p:txBody>
-      </p:sp>
-      <p:sp>
-        <p:nvSpPr>
-          <p:cNvPr id="10" name="Text 8"/>
-          <p:cNvSpPr/>
-          <p:nvPr/>
-        </p:nvSpPr>
-        <p:spPr>
-          <a:xfrm>
-            <a:off x="1298448" y="2606040"/>
-            <a:ext cx="1627632" cy="1170432"/>
-          </a:xfrm>
-          <a:prstGeom prst="rect">
-            <a:avLst/>
-          </a:prstGeom>
-          <a:noFill/>
-          <a:ln/>
-        </p:spPr>
-        <p:txBody>
-          <a:bodyPr wrap="square" lIns="0" tIns="0" rIns="0" bIns="0" rtlCol="0" anchor="t"/>
-          <a:lstStyle/>
-          <a:p>
-            <a:pPr indent="0" marL="0">
-              <a:lnSpc>
-                <a:spcPct val="92000"/>
-              </a:lnSpc>
-              <a:spcAft>
-                <a:spcPts val="500"/>
-              </a:spcAft>
-              <a:buNone/>
-            </a:pPr>
-            <a:r>
-              <a:rPr lang="en-US" sz="1100" dirty="0">
-                <a:solidFill>
-                  <a:srgbClr val="434A63"/>
-                </a:solidFill>
-                <a:latin typeface="Arial" pitchFamily="34" charset="0"/>
-                <a:ea typeface="Arial" pitchFamily="34" charset="-122"/>
-                <a:cs typeface="Arial" pitchFamily="34" charset="-120"/>
-              </a:rPr>
-              <a:t>Netzwerkwerkzeuge</a:t>
-            </a:r>
-            <a:endParaRPr lang="en-US" sz="1100" dirty="0"/>
-          </a:p>
-          <a:p>
-            <a:pPr indent="0" marL="0">
-              <a:lnSpc>
-                <a:spcPct val="92000"/>
-              </a:lnSpc>
-              <a:spcAft>
-                <a:spcPts val="500"/>
-              </a:spcAft>
-              <a:buNone/>
-            </a:pPr>
-            <a:r>
-              <a:rPr lang="en-US" sz="1100" dirty="0">
-                <a:solidFill>
-                  <a:srgbClr val="434A63"/>
-                </a:solidFill>
-                <a:latin typeface="Arial" pitchFamily="34" charset="0"/>
-                <a:ea typeface="Arial" pitchFamily="34" charset="-122"/>
-                <a:cs typeface="Arial" pitchFamily="34" charset="-120"/>
-              </a:rPr>
-              <a:t>Multipass für virtuelle Maschinen</a:t>
-            </a:r>
-            <a:endParaRPr lang="en-US" sz="1100" dirty="0"/>
-          </a:p>
-          <a:p>
-            <a:pPr indent="0" marL="0">
-              <a:lnSpc>
-                <a:spcPct val="92000"/>
-              </a:lnSpc>
-              <a:spcAft>
-                <a:spcPts val="500"/>
-              </a:spcAft>
-              <a:buNone/>
-            </a:pPr>
-            <a:r>
-              <a:rPr lang="en-US" sz="1100" dirty="0">
-                <a:solidFill>
-                  <a:srgbClr val="434A63"/>
-                </a:solidFill>
-                <a:latin typeface="Arial" pitchFamily="34" charset="0"/>
-                <a:ea typeface="Arial" pitchFamily="34" charset="-122"/>
-                <a:cs typeface="Arial" pitchFamily="34" charset="-120"/>
-              </a:rPr>
-              <a:t>Linux-Kommandozeile</a:t>
-            </a:r>
-            <a:endParaRPr lang="en-US" sz="1100" dirty="0"/>
-          </a:p>
-          <a:p>
-            <a:pPr indent="0" marL="0">
-              <a:lnSpc>
-                <a:spcPct val="92000"/>
-              </a:lnSpc>
-              <a:spcAft>
-                <a:spcPts val="500"/>
-              </a:spcAft>
-              <a:buNone/>
-            </a:pPr>
-            <a:r>
-              <a:rPr lang="en-US" sz="1100" dirty="0">
-                <a:solidFill>
-                  <a:srgbClr val="434A63"/>
-                </a:solidFill>
-                <a:latin typeface="Arial" pitchFamily="34" charset="0"/>
-                <a:ea typeface="Arial" pitchFamily="34" charset="-122"/>
-                <a:cs typeface="Arial" pitchFamily="34" charset="-120"/>
-              </a:rPr>
-              <a:t>Docker und Compose</a:t>
-            </a:r>
-            <a:endParaRPr lang="en-US" sz="1100" dirty="0"/>
-          </a:p>
-        </p:txBody>
-      </p:sp>
-      <p:sp>
-        <p:nvSpPr>
-          <p:cNvPr id="11" name="Shape 9"/>
-          <p:cNvSpPr/>
-          <p:nvPr/>
-        </p:nvSpPr>
-        <p:spPr>
-          <a:xfrm>
-            <a:off x="3310128" y="1975104"/>
-            <a:ext cx="2523744" cy="1920240"/>
-          </a:xfrm>
-          <a:prstGeom prst="rect">
-            <a:avLst/>
-          </a:prstGeom>
-          <a:solidFill>
-            <a:srgbClr val="F5F6FC"/>
-          </a:solidFill>
-          <a:ln/>
-        </p:spPr>
-      </p:sp>
-      <p:sp>
-        <p:nvSpPr>
-          <p:cNvPr id="12" name="Shape 10"/>
-          <p:cNvSpPr/>
-          <p:nvPr/>
-        </p:nvSpPr>
-        <p:spPr>
-          <a:xfrm>
-            <a:off x="3310128" y="1975104"/>
-            <a:ext cx="41148" cy="1920240"/>
-          </a:xfrm>
-          <a:prstGeom prst="rect">
-            <a:avLst/>
-          </a:prstGeom>
-          <a:solidFill>
-            <a:srgbClr val="0F7C86"/>
-          </a:solidFill>
-          <a:ln/>
-        </p:spPr>
-      </p:sp>
-      <p:sp>
-        <p:nvSpPr>
-          <p:cNvPr id="13" name="Text 11"/>
-          <p:cNvSpPr/>
-          <p:nvPr/>
-        </p:nvSpPr>
-        <p:spPr>
-          <a:xfrm>
-            <a:off x="3547872" y="2066544"/>
-            <a:ext cx="384048" cy="411480"/>
-          </a:xfrm>
-          <a:prstGeom prst="rect">
-            <a:avLst/>
-          </a:prstGeom>
-          <a:noFill/>
-          <a:ln/>
-        </p:spPr>
-        <p:txBody>
-          <a:bodyPr wrap="square" lIns="0" tIns="0" rIns="0" bIns="0" rtlCol="0" anchor="t"/>
-          <a:lstStyle/>
-          <a:p>
-            <a:pPr indent="0" marL="0">
-              <a:buNone/>
-            </a:pPr>
-            <a:r>
-              <a:rPr lang="en-US" sz="2000" b="1" dirty="0">
-                <a:solidFill>
-                  <a:srgbClr val="0F7C86"/>
-                </a:solidFill>
-                <a:latin typeface="Courier New" pitchFamily="34" charset="0"/>
-                <a:ea typeface="Courier New" pitchFamily="34" charset="-122"/>
-                <a:cs typeface="Courier New" pitchFamily="34" charset="-120"/>
-              </a:rPr>
-              <a:t>2</a:t>
-            </a:r>
-            <a:endParaRPr lang="en-US" sz="2000" dirty="0"/>
-          </a:p>
-        </p:txBody>
-      </p:sp>
-      <p:sp>
-        <p:nvSpPr>
-          <p:cNvPr id="14" name="Text 12"/>
-          <p:cNvSpPr/>
-          <p:nvPr/>
-        </p:nvSpPr>
-        <p:spPr>
-          <a:xfrm>
-            <a:off x="4041648" y="2121408"/>
-            <a:ext cx="1627632" cy="438912"/>
-          </a:xfrm>
-          <a:prstGeom prst="rect">
-            <a:avLst/>
-          </a:prstGeom>
-          <a:noFill/>
-          <a:ln/>
-        </p:spPr>
-        <p:txBody>
-          <a:bodyPr wrap="square" lIns="0" tIns="0" rIns="0" bIns="0" rtlCol="0" anchor="t"/>
-          <a:lstStyle/>
-          <a:p>
-            <a:pPr indent="0" marL="0">
-              <a:buNone/>
-            </a:pPr>
-            <a:r>
-              <a:rPr lang="en-US" sz="1200" b="1" dirty="0">
-                <a:solidFill>
-                  <a:srgbClr val="272E52"/>
-                </a:solidFill>
-                <a:latin typeface="Arial" pitchFamily="34" charset="0"/>
-                <a:ea typeface="Arial" pitchFamily="34" charset="-122"/>
-                <a:cs typeface="Arial" pitchFamily="34" charset="-120"/>
-              </a:rPr>
-              <a:t>Laufender Betrieb</a:t>
-            </a:r>
-            <a:endParaRPr lang="en-US" sz="1200" dirty="0"/>
-          </a:p>
-        </p:txBody>
-      </p:sp>
-      <p:sp>
-        <p:nvSpPr>
-          <p:cNvPr id="15" name="Text 13"/>
-          <p:cNvSpPr/>
-          <p:nvPr/>
-        </p:nvSpPr>
-        <p:spPr>
-          <a:xfrm>
-            <a:off x="4041648" y="2606040"/>
-            <a:ext cx="1627632" cy="1170432"/>
-          </a:xfrm>
-          <a:prstGeom prst="rect">
-            <a:avLst/>
-          </a:prstGeom>
-          <a:noFill/>
-          <a:ln/>
-        </p:spPr>
-        <p:txBody>
-          <a:bodyPr wrap="square" lIns="0" tIns="0" rIns="0" bIns="0" rtlCol="0" anchor="t"/>
-          <a:lstStyle/>
-          <a:p>
-            <a:pPr indent="0" marL="0">
-              <a:lnSpc>
-                <a:spcPct val="92000"/>
-              </a:lnSpc>
-              <a:spcAft>
-                <a:spcPts val="500"/>
-              </a:spcAft>
-              <a:buNone/>
-            </a:pPr>
-            <a:r>
-              <a:rPr lang="en-US" sz="1100" dirty="0">
-                <a:solidFill>
-                  <a:srgbClr val="434A63"/>
-                </a:solidFill>
-                <a:latin typeface="Arial" pitchFamily="34" charset="0"/>
-                <a:ea typeface="Arial" pitchFamily="34" charset="-122"/>
-                <a:cs typeface="Arial" pitchFamily="34" charset="-120"/>
-              </a:rPr>
-              <a:t>Prometheus und Grafana</a:t>
-            </a:r>
-            <a:endParaRPr lang="en-US" sz="1100" dirty="0"/>
-          </a:p>
-          <a:p>
-            <a:pPr indent="0" marL="0">
-              <a:lnSpc>
-                <a:spcPct val="92000"/>
-              </a:lnSpc>
-              <a:spcAft>
-                <a:spcPts val="500"/>
-              </a:spcAft>
-              <a:buNone/>
-            </a:pPr>
-            <a:r>
-              <a:rPr lang="en-US" sz="1100" dirty="0">
-                <a:solidFill>
-                  <a:srgbClr val="434A63"/>
-                </a:solidFill>
-                <a:latin typeface="Arial" pitchFamily="34" charset="0"/>
-                <a:ea typeface="Arial" pitchFamily="34" charset="-122"/>
-                <a:cs typeface="Arial" pitchFamily="34" charset="-120"/>
-              </a:rPr>
-              <a:t>Kubernetes und Helm</a:t>
-            </a:r>
-            <a:endParaRPr lang="en-US" sz="1100" dirty="0"/>
-          </a:p>
-          <a:p>
-            <a:pPr indent="0" marL="0">
-              <a:lnSpc>
-                <a:spcPct val="92000"/>
-              </a:lnSpc>
-              <a:spcAft>
-                <a:spcPts val="500"/>
-              </a:spcAft>
-              <a:buNone/>
-            </a:pPr>
-            <a:r>
-              <a:rPr lang="en-US" sz="1100" dirty="0">
-                <a:solidFill>
-                  <a:srgbClr val="434A63"/>
-                </a:solidFill>
-                <a:latin typeface="Arial" pitchFamily="34" charset="0"/>
-                <a:ea typeface="Arial" pitchFamily="34" charset="-122"/>
-                <a:cs typeface="Arial" pitchFamily="34" charset="-120"/>
-              </a:rPr>
-              <a:t>Git und GitHub</a:t>
-            </a:r>
-            <a:endParaRPr lang="en-US" sz="1100" dirty="0"/>
-          </a:p>
-          <a:p>
-            <a:pPr indent="0" marL="0">
-              <a:lnSpc>
-                <a:spcPct val="92000"/>
-              </a:lnSpc>
-              <a:spcAft>
-                <a:spcPts val="500"/>
-              </a:spcAft>
-              <a:buNone/>
-            </a:pPr>
-            <a:r>
-              <a:rPr lang="en-US" sz="1100" dirty="0">
-                <a:solidFill>
-                  <a:srgbClr val="434A63"/>
-                </a:solidFill>
-                <a:latin typeface="Arial" pitchFamily="34" charset="0"/>
-                <a:ea typeface="Arial" pitchFamily="34" charset="-122"/>
-                <a:cs typeface="Arial" pitchFamily="34" charset="-120"/>
-              </a:rPr>
-              <a:t>GitHub Actions</a:t>
-            </a:r>
-            <a:endParaRPr lang="en-US" sz="1100" dirty="0"/>
-          </a:p>
-        </p:txBody>
-      </p:sp>
-      <p:sp>
-        <p:nvSpPr>
-          <p:cNvPr id="16" name="Shape 14"/>
-          <p:cNvSpPr/>
-          <p:nvPr/>
-        </p:nvSpPr>
-        <p:spPr>
-          <a:xfrm>
-            <a:off x="6053328" y="1975104"/>
-            <a:ext cx="2523744" cy="1920240"/>
-          </a:xfrm>
-          <a:prstGeom prst="rect">
-            <a:avLst/>
-          </a:prstGeom>
-          <a:solidFill>
-            <a:srgbClr val="F5F6FC"/>
-          </a:solidFill>
-          <a:ln/>
-        </p:spPr>
-      </p:sp>
-      <p:sp>
-        <p:nvSpPr>
-          <p:cNvPr id="17" name="Shape 15"/>
-          <p:cNvSpPr/>
-          <p:nvPr/>
-        </p:nvSpPr>
-        <p:spPr>
-          <a:xfrm>
-            <a:off x="6053328" y="1975104"/>
-            <a:ext cx="41148" cy="1920240"/>
-          </a:xfrm>
-          <a:prstGeom prst="rect">
-            <a:avLst/>
-          </a:prstGeom>
-          <a:solidFill>
-            <a:srgbClr val="A96D12"/>
-          </a:solidFill>
-          <a:ln/>
-        </p:spPr>
-      </p:sp>
-      <p:sp>
-        <p:nvSpPr>
-          <p:cNvPr id="18" name="Text 16"/>
-          <p:cNvSpPr/>
-          <p:nvPr/>
-        </p:nvSpPr>
-        <p:spPr>
-          <a:xfrm>
-            <a:off x="6291072" y="2066544"/>
-            <a:ext cx="384048" cy="411480"/>
-          </a:xfrm>
-          <a:prstGeom prst="rect">
-            <a:avLst/>
-          </a:prstGeom>
-          <a:noFill/>
-          <a:ln/>
-        </p:spPr>
-        <p:txBody>
-          <a:bodyPr wrap="square" lIns="0" tIns="0" rIns="0" bIns="0" rtlCol="0" anchor="t"/>
-          <a:lstStyle/>
-          <a:p>
-            <a:pPr indent="0" marL="0">
-              <a:buNone/>
-            </a:pPr>
-            <a:r>
-              <a:rPr lang="en-US" sz="2000" b="1" dirty="0">
-                <a:solidFill>
-                  <a:srgbClr val="A96D12"/>
-                </a:solidFill>
-                <a:latin typeface="Courier New" pitchFamily="34" charset="0"/>
-                <a:ea typeface="Courier New" pitchFamily="34" charset="-122"/>
-                <a:cs typeface="Courier New" pitchFamily="34" charset="-120"/>
-              </a:rPr>
-              <a:t>3</a:t>
-            </a:r>
-            <a:endParaRPr lang="en-US" sz="2000" dirty="0"/>
-          </a:p>
-        </p:txBody>
-      </p:sp>
-      <p:sp>
-        <p:nvSpPr>
-          <p:cNvPr id="19" name="Text 17"/>
-          <p:cNvSpPr/>
-          <p:nvPr/>
-        </p:nvSpPr>
-        <p:spPr>
-          <a:xfrm>
-            <a:off x="6784848" y="2121408"/>
-            <a:ext cx="1627632" cy="438912"/>
-          </a:xfrm>
-          <a:prstGeom prst="rect">
-            <a:avLst/>
-          </a:prstGeom>
-          <a:noFill/>
-          <a:ln/>
-        </p:spPr>
-        <p:txBody>
-          <a:bodyPr wrap="square" lIns="0" tIns="0" rIns="0" bIns="0" rtlCol="0" anchor="t"/>
-          <a:lstStyle/>
-          <a:p>
-            <a:pPr indent="0" marL="0">
-              <a:buNone/>
-            </a:pPr>
-            <a:r>
-              <a:rPr lang="en-US" sz="1200" b="1" dirty="0">
-                <a:solidFill>
-                  <a:srgbClr val="272E52"/>
-                </a:solidFill>
-                <a:latin typeface="Arial" pitchFamily="34" charset="0"/>
-                <a:ea typeface="Arial" pitchFamily="34" charset="-122"/>
-                <a:cs typeface="Arial" pitchFamily="34" charset="-120"/>
-              </a:rPr>
-              <a:t>Qualität und Sicherheit</a:t>
-            </a:r>
-            <a:endParaRPr lang="en-US" sz="1200" dirty="0"/>
-          </a:p>
-        </p:txBody>
-      </p:sp>
-      <p:sp>
-        <p:nvSpPr>
-          <p:cNvPr id="20" name="Text 18"/>
-          <p:cNvSpPr/>
-          <p:nvPr/>
-        </p:nvSpPr>
-        <p:spPr>
-          <a:xfrm>
-            <a:off x="6784848" y="2606040"/>
-            <a:ext cx="1627632" cy="1170432"/>
-          </a:xfrm>
-          <a:prstGeom prst="rect">
-            <a:avLst/>
-          </a:prstGeom>
-          <a:noFill/>
-          <a:ln/>
-        </p:spPr>
-        <p:txBody>
-          <a:bodyPr wrap="square" lIns="0" tIns="0" rIns="0" bIns="0" rtlCol="0" anchor="t"/>
-          <a:lstStyle/>
-          <a:p>
-            <a:pPr indent="0" marL="0">
-              <a:lnSpc>
-                <a:spcPct val="92000"/>
-              </a:lnSpc>
-              <a:spcAft>
-                <a:spcPts val="500"/>
-              </a:spcAft>
-              <a:buNone/>
-            </a:pPr>
-            <a:r>
-              <a:rPr lang="en-US" sz="1100" dirty="0">
-                <a:solidFill>
-                  <a:srgbClr val="434A63"/>
-                </a:solidFill>
-                <a:latin typeface="Arial" pitchFamily="34" charset="0"/>
-                <a:ea typeface="Arial" pitchFamily="34" charset="-122"/>
-                <a:cs typeface="Arial" pitchFamily="34" charset="-120"/>
-              </a:rPr>
-              <a:t>Schwachstellen-Scanner</a:t>
-            </a:r>
-            <a:endParaRPr lang="en-US" sz="1100" dirty="0"/>
-          </a:p>
-          <a:p>
-            <a:pPr indent="0" marL="0">
-              <a:lnSpc>
-                <a:spcPct val="92000"/>
-              </a:lnSpc>
-              <a:spcAft>
-                <a:spcPts val="500"/>
-              </a:spcAft>
-              <a:buNone/>
-            </a:pPr>
-            <a:r>
-              <a:rPr lang="en-US" sz="1100" dirty="0">
-                <a:solidFill>
-                  <a:srgbClr val="434A63"/>
-                </a:solidFill>
-                <a:latin typeface="Arial" pitchFamily="34" charset="0"/>
-                <a:ea typeface="Arial" pitchFamily="34" charset="-122"/>
-                <a:cs typeface="Arial" pitchFamily="34" charset="-120"/>
-              </a:rPr>
-              <a:t>Testverfahren und Testpläne</a:t>
-            </a:r>
-            <a:endParaRPr lang="en-US" sz="1100" dirty="0"/>
-          </a:p>
-          <a:p>
-            <a:pPr indent="0" marL="0">
-              <a:lnSpc>
-                <a:spcPct val="92000"/>
-              </a:lnSpc>
-              <a:spcAft>
-                <a:spcPts val="500"/>
-              </a:spcAft>
-              <a:buNone/>
-            </a:pPr>
-            <a:r>
-              <a:rPr lang="en-US" sz="1100" dirty="0">
-                <a:solidFill>
-                  <a:srgbClr val="434A63"/>
-                </a:solidFill>
-                <a:latin typeface="Arial" pitchFamily="34" charset="0"/>
-                <a:ea typeface="Arial" pitchFamily="34" charset="-122"/>
-                <a:cs typeface="Arial" pitchFamily="34" charset="-120"/>
-              </a:rPr>
-              <a:t>Risikoanalyse</a:t>
-            </a:r>
-            <a:endParaRPr lang="en-US" sz="1100" dirty="0"/>
-          </a:p>
-          <a:p>
-            <a:pPr indent="0" marL="0">
-              <a:lnSpc>
-                <a:spcPct val="92000"/>
-              </a:lnSpc>
-              <a:spcAft>
-                <a:spcPts val="500"/>
-              </a:spcAft>
-              <a:buNone/>
-            </a:pPr>
-            <a:r>
-              <a:rPr lang="en-US" sz="1100" dirty="0">
-                <a:solidFill>
-                  <a:srgbClr val="434A63"/>
-                </a:solidFill>
-                <a:latin typeface="Arial" pitchFamily="34" charset="0"/>
-                <a:ea typeface="Arial" pitchFamily="34" charset="-122"/>
-                <a:cs typeface="Arial" pitchFamily="34" charset="-120"/>
-              </a:rPr>
-              <a:t>Vorfallbearbeitung</a:t>
-            </a:r>
-            <a:endParaRPr lang="en-US" sz="1100" dirty="0"/>
-          </a:p>
-        </p:txBody>
-      </p:sp>
-      <p:sp>
-        <p:nvSpPr>
-          <p:cNvPr id="21" name="Shape 19"/>
-          <p:cNvSpPr/>
-          <p:nvPr/>
-        </p:nvSpPr>
-        <p:spPr>
-          <a:xfrm>
-            <a:off x="566928" y="4160520"/>
-            <a:ext cx="32004" cy="256032"/>
-          </a:xfrm>
-          <a:prstGeom prst="rect">
-            <a:avLst/>
-          </a:prstGeom>
-          <a:solidFill>
-            <a:srgbClr val="3843AF"/>
-          </a:solidFill>
-          <a:ln/>
-        </p:spPr>
-      </p:sp>
-      <p:sp>
-        <p:nvSpPr>
-          <p:cNvPr id="22" name="Text 20"/>
-          <p:cNvSpPr/>
-          <p:nvPr/>
-        </p:nvSpPr>
-        <p:spPr>
-          <a:xfrm>
-            <a:off x="749808" y="4114800"/>
-            <a:ext cx="7827264" cy="402336"/>
-          </a:xfrm>
-          <a:prstGeom prst="rect">
-            <a:avLst/>
-          </a:prstGeom>
-          <a:noFill/>
-          <a:ln/>
-        </p:spPr>
-        <p:txBody>
-          <a:bodyPr wrap="square" lIns="0" tIns="0" rIns="0" bIns="0" rtlCol="0" anchor="ctr"/>
-          <a:lstStyle/>
-          <a:p>
-            <a:pPr indent="0" marL="0">
-              <a:buNone/>
-            </a:pPr>
-            <a:r>
-              <a:rPr lang="en-US" sz="1200" b="1" dirty="0">
-                <a:solidFill>
-                  <a:srgbClr val="434A63"/>
-                </a:solidFill>
-                <a:latin typeface="Arial" pitchFamily="34" charset="0"/>
-                <a:ea typeface="Arial" pitchFamily="34" charset="-122"/>
-                <a:cs typeface="Arial" pitchFamily="34" charset="-120"/>
-              </a:rPr>
-              <a:t>Alles wird gemeinsam installiert – bringt nur euren Rechner mit.</a:t>
-            </a:r>
-            <a:endParaRPr lang="en-US" sz="1200" dirty="0"/>
-          </a:p>
-        </p:txBody>
-      </p:sp>
-      <p:sp>
-        <p:nvSpPr>
-          <p:cNvPr id="23" name="Shape 21"/>
-          <p:cNvSpPr/>
-          <p:nvPr/>
-        </p:nvSpPr>
-        <p:spPr>
-          <a:xfrm>
-            <a:off x="566928" y="4631436"/>
-            <a:ext cx="8010144" cy="0"/>
-          </a:xfrm>
-          <a:prstGeom prst="line">
-            <a:avLst/>
-          </a:prstGeom>
-          <a:noFill/>
           <a:ln w="9525">
             <a:solidFill>
               <a:srgbClr val="DFE3F0"/>
@@ -6882,9 +6194,1150 @@
           </a:ln>
         </p:spPr>
       </p:sp>
-      <p:sp>
-        <p:nvSpPr>
-          <p:cNvPr id="24" name="Text 22"/>
+      <p:pic>
+        <p:nvPicPr>
+          <p:cNvPr id="8" name="Image 0" descr="/Users/jacobmenge/Desktop/kurs-unterlagen/folien/assets/icons/ubuntu-E95420.png">    </p:cNvPr>
+          <p:cNvPicPr>
+            <a:picLocks noChangeAspect="1"/>
+          </p:cNvPicPr>
+          <p:nvPr/>
+        </p:nvPicPr>
+        <p:blipFill>
+          <a:blip r:embed="rId1"/>
+          <a:stretch>
+            <a:fillRect/>
+          </a:stretch>
+        </p:blipFill>
+        <p:spPr>
+          <a:xfrm>
+            <a:off x="694944" y="2304288"/>
+            <a:ext cx="237744" cy="237744"/>
+          </a:xfrm>
+          <a:prstGeom prst="rect">
+            <a:avLst/>
+          </a:prstGeom>
+        </p:spPr>
+      </p:pic>
+      <p:sp>
+        <p:nvSpPr>
+          <p:cNvPr id="9" name="Text 6"/>
+          <p:cNvSpPr/>
+          <p:nvPr/>
+        </p:nvSpPr>
+        <p:spPr>
+          <a:xfrm>
+            <a:off x="1042416" y="2231136"/>
+            <a:ext cx="1956816" cy="384048"/>
+          </a:xfrm>
+          <a:prstGeom prst="rect">
+            <a:avLst/>
+          </a:prstGeom>
+          <a:noFill/>
+          <a:ln/>
+        </p:spPr>
+        <p:txBody>
+          <a:bodyPr wrap="square" lIns="0" tIns="0" rIns="0" bIns="0" rtlCol="0" anchor="ctr"/>
+          <a:lstStyle/>
+          <a:p>
+            <a:pPr indent="0" marL="0">
+              <a:buNone/>
+            </a:pPr>
+            <a:r>
+              <a:rPr lang="en-US" sz="1150" b="1" dirty="0">
+                <a:solidFill>
+                  <a:srgbClr val="272E52"/>
+                </a:solidFill>
+                <a:latin typeface="Arial" pitchFamily="34" charset="0"/>
+                <a:ea typeface="Arial" pitchFamily="34" charset="-122"/>
+                <a:cs typeface="Arial" pitchFamily="34" charset="-120"/>
+              </a:rPr>
+              <a:t>Ubuntu Linux</a:t>
+            </a:r>
+            <a:endParaRPr lang="en-US" sz="1150" dirty="0"/>
+          </a:p>
+        </p:txBody>
+      </p:sp>
+      <p:sp>
+        <p:nvSpPr>
+          <p:cNvPr id="10" name="Shape 7"/>
+          <p:cNvSpPr/>
+          <p:nvPr/>
+        </p:nvSpPr>
+        <p:spPr>
+          <a:xfrm>
+            <a:off x="566928" y="2715768"/>
+            <a:ext cx="2560320" cy="384048"/>
+          </a:xfrm>
+          <a:prstGeom prst="roundRect">
+            <a:avLst>
+              <a:gd name="adj" fmla="val 11905"/>
+            </a:avLst>
+          </a:prstGeom>
+          <a:solidFill>
+            <a:srgbClr val="F5F6FC"/>
+          </a:solidFill>
+          <a:ln w="9525">
+            <a:solidFill>
+              <a:srgbClr val="DFE3F0"/>
+            </a:solidFill>
+            <a:prstDash val="solid"/>
+          </a:ln>
+        </p:spPr>
+      </p:sp>
+      <p:pic>
+        <p:nvPicPr>
+          <p:cNvPr id="11" name="Image 1" descr="/Users/jacobmenge/Desktop/kurs-unterlagen/folien/assets/icons/canonical-E95420.png">    </p:cNvPr>
+          <p:cNvPicPr>
+            <a:picLocks noChangeAspect="1"/>
+          </p:cNvPicPr>
+          <p:nvPr/>
+        </p:nvPicPr>
+        <p:blipFill>
+          <a:blip r:embed="rId2"/>
+          <a:stretch>
+            <a:fillRect/>
+          </a:stretch>
+        </p:blipFill>
+        <p:spPr>
+          <a:xfrm>
+            <a:off x="694944" y="2788920"/>
+            <a:ext cx="237744" cy="237744"/>
+          </a:xfrm>
+          <a:prstGeom prst="rect">
+            <a:avLst/>
+          </a:prstGeom>
+        </p:spPr>
+      </p:pic>
+      <p:sp>
+        <p:nvSpPr>
+          <p:cNvPr id="12" name="Text 8"/>
+          <p:cNvSpPr/>
+          <p:nvPr/>
+        </p:nvSpPr>
+        <p:spPr>
+          <a:xfrm>
+            <a:off x="1042416" y="2715768"/>
+            <a:ext cx="1956816" cy="384048"/>
+          </a:xfrm>
+          <a:prstGeom prst="rect">
+            <a:avLst/>
+          </a:prstGeom>
+          <a:noFill/>
+          <a:ln/>
+        </p:spPr>
+        <p:txBody>
+          <a:bodyPr wrap="square" lIns="0" tIns="0" rIns="0" bIns="0" rtlCol="0" anchor="ctr"/>
+          <a:lstStyle/>
+          <a:p>
+            <a:pPr indent="0" marL="0">
+              <a:buNone/>
+            </a:pPr>
+            <a:r>
+              <a:rPr lang="en-US" sz="1150" b="1" dirty="0">
+                <a:solidFill>
+                  <a:srgbClr val="272E52"/>
+                </a:solidFill>
+                <a:latin typeface="Arial" pitchFamily="34" charset="0"/>
+                <a:ea typeface="Arial" pitchFamily="34" charset="-122"/>
+                <a:cs typeface="Arial" pitchFamily="34" charset="-120"/>
+              </a:rPr>
+              <a:t>Multipass</a:t>
+            </a:r>
+            <a:endParaRPr lang="en-US" sz="1150" dirty="0"/>
+          </a:p>
+        </p:txBody>
+      </p:sp>
+      <p:sp>
+        <p:nvSpPr>
+          <p:cNvPr id="13" name="Shape 9"/>
+          <p:cNvSpPr/>
+          <p:nvPr/>
+        </p:nvSpPr>
+        <p:spPr>
+          <a:xfrm>
+            <a:off x="566928" y="3200400"/>
+            <a:ext cx="2560320" cy="384048"/>
+          </a:xfrm>
+          <a:prstGeom prst="roundRect">
+            <a:avLst>
+              <a:gd name="adj" fmla="val 11905"/>
+            </a:avLst>
+          </a:prstGeom>
+          <a:solidFill>
+            <a:srgbClr val="F5F6FC"/>
+          </a:solidFill>
+          <a:ln w="9525">
+            <a:solidFill>
+              <a:srgbClr val="DFE3F0"/>
+            </a:solidFill>
+            <a:prstDash val="solid"/>
+          </a:ln>
+        </p:spPr>
+      </p:sp>
+      <p:pic>
+        <p:nvPicPr>
+          <p:cNvPr id="14" name="Image 2" descr="/Users/jacobmenge/Desktop/kurs-unterlagen/folien/assets/icons/docker-2496ED.png">    </p:cNvPr>
+          <p:cNvPicPr>
+            <a:picLocks noChangeAspect="1"/>
+          </p:cNvPicPr>
+          <p:nvPr/>
+        </p:nvPicPr>
+        <p:blipFill>
+          <a:blip r:embed="rId3"/>
+          <a:stretch>
+            <a:fillRect/>
+          </a:stretch>
+        </p:blipFill>
+        <p:spPr>
+          <a:xfrm>
+            <a:off x="694944" y="3273552"/>
+            <a:ext cx="237744" cy="237744"/>
+          </a:xfrm>
+          <a:prstGeom prst="rect">
+            <a:avLst/>
+          </a:prstGeom>
+        </p:spPr>
+      </p:pic>
+      <p:sp>
+        <p:nvSpPr>
+          <p:cNvPr id="15" name="Text 10"/>
+          <p:cNvSpPr/>
+          <p:nvPr/>
+        </p:nvSpPr>
+        <p:spPr>
+          <a:xfrm>
+            <a:off x="1042416" y="3200400"/>
+            <a:ext cx="1956816" cy="384048"/>
+          </a:xfrm>
+          <a:prstGeom prst="rect">
+            <a:avLst/>
+          </a:prstGeom>
+          <a:noFill/>
+          <a:ln/>
+        </p:spPr>
+        <p:txBody>
+          <a:bodyPr wrap="square" lIns="0" tIns="0" rIns="0" bIns="0" rtlCol="0" anchor="ctr"/>
+          <a:lstStyle/>
+          <a:p>
+            <a:pPr indent="0" marL="0">
+              <a:buNone/>
+            </a:pPr>
+            <a:r>
+              <a:rPr lang="en-US" sz="1150" b="1" dirty="0">
+                <a:solidFill>
+                  <a:srgbClr val="272E52"/>
+                </a:solidFill>
+                <a:latin typeface="Arial" pitchFamily="34" charset="0"/>
+                <a:ea typeface="Arial" pitchFamily="34" charset="-122"/>
+                <a:cs typeface="Arial" pitchFamily="34" charset="-120"/>
+              </a:rPr>
+              <a:t>Docker &amp; Compose</a:t>
+            </a:r>
+            <a:endParaRPr lang="en-US" sz="1150" dirty="0"/>
+          </a:p>
+        </p:txBody>
+      </p:sp>
+      <p:sp>
+        <p:nvSpPr>
+          <p:cNvPr id="16" name="Shape 11"/>
+          <p:cNvSpPr/>
+          <p:nvPr/>
+        </p:nvSpPr>
+        <p:spPr>
+          <a:xfrm>
+            <a:off x="566928" y="3685032"/>
+            <a:ext cx="2560320" cy="384048"/>
+          </a:xfrm>
+          <a:prstGeom prst="roundRect">
+            <a:avLst>
+              <a:gd name="adj" fmla="val 11905"/>
+            </a:avLst>
+          </a:prstGeom>
+          <a:solidFill>
+            <a:srgbClr val="F5F6FC"/>
+          </a:solidFill>
+          <a:ln w="9525">
+            <a:solidFill>
+              <a:srgbClr val="DFE3F0"/>
+            </a:solidFill>
+            <a:prstDash val="solid"/>
+          </a:ln>
+        </p:spPr>
+      </p:sp>
+      <p:pic>
+        <p:nvPicPr>
+          <p:cNvPr id="17" name="Image 3" descr="/Users/jacobmenge/Desktop/kurs-unterlagen/folien/assets/icons/wireshark-1679A7.png">    </p:cNvPr>
+          <p:cNvPicPr>
+            <a:picLocks noChangeAspect="1"/>
+          </p:cNvPicPr>
+          <p:nvPr/>
+        </p:nvPicPr>
+        <p:blipFill>
+          <a:blip r:embed="rId4"/>
+          <a:stretch>
+            <a:fillRect/>
+          </a:stretch>
+        </p:blipFill>
+        <p:spPr>
+          <a:xfrm>
+            <a:off x="694944" y="3758184"/>
+            <a:ext cx="237744" cy="237744"/>
+          </a:xfrm>
+          <a:prstGeom prst="rect">
+            <a:avLst/>
+          </a:prstGeom>
+        </p:spPr>
+      </p:pic>
+      <p:sp>
+        <p:nvSpPr>
+          <p:cNvPr id="18" name="Text 12"/>
+          <p:cNvSpPr/>
+          <p:nvPr/>
+        </p:nvSpPr>
+        <p:spPr>
+          <a:xfrm>
+            <a:off x="1042416" y="3685032"/>
+            <a:ext cx="1956816" cy="384048"/>
+          </a:xfrm>
+          <a:prstGeom prst="rect">
+            <a:avLst/>
+          </a:prstGeom>
+          <a:noFill/>
+          <a:ln/>
+        </p:spPr>
+        <p:txBody>
+          <a:bodyPr wrap="square" lIns="0" tIns="0" rIns="0" bIns="0" rtlCol="0" anchor="ctr"/>
+          <a:lstStyle/>
+          <a:p>
+            <a:pPr indent="0" marL="0">
+              <a:buNone/>
+            </a:pPr>
+            <a:r>
+              <a:rPr lang="en-US" sz="1150" b="1" dirty="0">
+                <a:solidFill>
+                  <a:srgbClr val="272E52"/>
+                </a:solidFill>
+                <a:latin typeface="Arial" pitchFamily="34" charset="0"/>
+                <a:ea typeface="Arial" pitchFamily="34" charset="-122"/>
+                <a:cs typeface="Arial" pitchFamily="34" charset="-120"/>
+              </a:rPr>
+              <a:t>Netzwerk-Werkzeuge</a:t>
+            </a:r>
+            <a:endParaRPr lang="en-US" sz="1150" dirty="0"/>
+          </a:p>
+        </p:txBody>
+      </p:sp>
+      <p:sp>
+        <p:nvSpPr>
+          <p:cNvPr id="19" name="Text 13"/>
+          <p:cNvSpPr/>
+          <p:nvPr/>
+        </p:nvSpPr>
+        <p:spPr>
+          <a:xfrm>
+            <a:off x="3291840" y="1938528"/>
+            <a:ext cx="2560320" cy="256032"/>
+          </a:xfrm>
+          <a:prstGeom prst="rect">
+            <a:avLst/>
+          </a:prstGeom>
+          <a:noFill/>
+          <a:ln/>
+        </p:spPr>
+        <p:txBody>
+          <a:bodyPr wrap="square" lIns="0" tIns="0" rIns="0" bIns="0" rtlCol="0" anchor="ctr"/>
+          <a:lstStyle/>
+          <a:p>
+            <a:pPr indent="0" marL="0">
+              <a:buNone/>
+            </a:pPr>
+            <a:r>
+              <a:rPr lang="en-US" sz="1100" b="1" dirty="0">
+                <a:solidFill>
+                  <a:srgbClr val="5C6377"/>
+                </a:solidFill>
+                <a:latin typeface="Arial" pitchFamily="34" charset="0"/>
+                <a:ea typeface="Arial" pitchFamily="34" charset="-122"/>
+                <a:cs typeface="Arial" pitchFamily="34" charset="-120"/>
+              </a:rPr>
+              <a:t>Thema 2 · Laufender Betrieb</a:t>
+            </a:r>
+            <a:endParaRPr lang="en-US" sz="1100" dirty="0"/>
+          </a:p>
+        </p:txBody>
+      </p:sp>
+      <p:sp>
+        <p:nvSpPr>
+          <p:cNvPr id="20" name="Shape 14"/>
+          <p:cNvSpPr/>
+          <p:nvPr/>
+        </p:nvSpPr>
+        <p:spPr>
+          <a:xfrm>
+            <a:off x="3291840" y="2231136"/>
+            <a:ext cx="2560320" cy="384048"/>
+          </a:xfrm>
+          <a:prstGeom prst="roundRect">
+            <a:avLst>
+              <a:gd name="adj" fmla="val 11905"/>
+            </a:avLst>
+          </a:prstGeom>
+          <a:solidFill>
+            <a:srgbClr val="F5F6FC"/>
+          </a:solidFill>
+          <a:ln w="9525">
+            <a:solidFill>
+              <a:srgbClr val="DFE3F0"/>
+            </a:solidFill>
+            <a:prstDash val="solid"/>
+          </a:ln>
+        </p:spPr>
+      </p:sp>
+      <p:pic>
+        <p:nvPicPr>
+          <p:cNvPr id="21" name="Image 4" descr="/Users/jacobmenge/Desktop/kurs-unterlagen/folien/assets/icons/prometheus-E6522C.png">    </p:cNvPr>
+          <p:cNvPicPr>
+            <a:picLocks noChangeAspect="1"/>
+          </p:cNvPicPr>
+          <p:nvPr/>
+        </p:nvPicPr>
+        <p:blipFill>
+          <a:blip r:embed="rId5"/>
+          <a:stretch>
+            <a:fillRect/>
+          </a:stretch>
+        </p:blipFill>
+        <p:spPr>
+          <a:xfrm>
+            <a:off x="3419856" y="2304288"/>
+            <a:ext cx="237744" cy="237744"/>
+          </a:xfrm>
+          <a:prstGeom prst="rect">
+            <a:avLst/>
+          </a:prstGeom>
+        </p:spPr>
+      </p:pic>
+      <p:sp>
+        <p:nvSpPr>
+          <p:cNvPr id="22" name="Text 15"/>
+          <p:cNvSpPr/>
+          <p:nvPr/>
+        </p:nvSpPr>
+        <p:spPr>
+          <a:xfrm>
+            <a:off x="3767328" y="2231136"/>
+            <a:ext cx="1956816" cy="384048"/>
+          </a:xfrm>
+          <a:prstGeom prst="rect">
+            <a:avLst/>
+          </a:prstGeom>
+          <a:noFill/>
+          <a:ln/>
+        </p:spPr>
+        <p:txBody>
+          <a:bodyPr wrap="square" lIns="0" tIns="0" rIns="0" bIns="0" rtlCol="0" anchor="ctr"/>
+          <a:lstStyle/>
+          <a:p>
+            <a:pPr indent="0" marL="0">
+              <a:buNone/>
+            </a:pPr>
+            <a:r>
+              <a:rPr lang="en-US" sz="1150" b="1" dirty="0">
+                <a:solidFill>
+                  <a:srgbClr val="272E52"/>
+                </a:solidFill>
+                <a:latin typeface="Arial" pitchFamily="34" charset="0"/>
+                <a:ea typeface="Arial" pitchFamily="34" charset="-122"/>
+                <a:cs typeface="Arial" pitchFamily="34" charset="-120"/>
+              </a:rPr>
+              <a:t>Prometheus</a:t>
+            </a:r>
+            <a:endParaRPr lang="en-US" sz="1150" dirty="0"/>
+          </a:p>
+        </p:txBody>
+      </p:sp>
+      <p:sp>
+        <p:nvSpPr>
+          <p:cNvPr id="23" name="Shape 16"/>
+          <p:cNvSpPr/>
+          <p:nvPr/>
+        </p:nvSpPr>
+        <p:spPr>
+          <a:xfrm>
+            <a:off x="3291840" y="2715768"/>
+            <a:ext cx="2560320" cy="384048"/>
+          </a:xfrm>
+          <a:prstGeom prst="roundRect">
+            <a:avLst>
+              <a:gd name="adj" fmla="val 11905"/>
+            </a:avLst>
+          </a:prstGeom>
+          <a:solidFill>
+            <a:srgbClr val="F5F6FC"/>
+          </a:solidFill>
+          <a:ln w="9525">
+            <a:solidFill>
+              <a:srgbClr val="DFE3F0"/>
+            </a:solidFill>
+            <a:prstDash val="solid"/>
+          </a:ln>
+        </p:spPr>
+      </p:sp>
+      <p:pic>
+        <p:nvPicPr>
+          <p:cNvPr id="24" name="Image 5" descr="/Users/jacobmenge/Desktop/kurs-unterlagen/folien/assets/icons/grafana-F46800.png">    </p:cNvPr>
+          <p:cNvPicPr>
+            <a:picLocks noChangeAspect="1"/>
+          </p:cNvPicPr>
+          <p:nvPr/>
+        </p:nvPicPr>
+        <p:blipFill>
+          <a:blip r:embed="rId6"/>
+          <a:stretch>
+            <a:fillRect/>
+          </a:stretch>
+        </p:blipFill>
+        <p:spPr>
+          <a:xfrm>
+            <a:off x="3419856" y="2788920"/>
+            <a:ext cx="237744" cy="237744"/>
+          </a:xfrm>
+          <a:prstGeom prst="rect">
+            <a:avLst/>
+          </a:prstGeom>
+        </p:spPr>
+      </p:pic>
+      <p:sp>
+        <p:nvSpPr>
+          <p:cNvPr id="25" name="Text 17"/>
+          <p:cNvSpPr/>
+          <p:nvPr/>
+        </p:nvSpPr>
+        <p:spPr>
+          <a:xfrm>
+            <a:off x="3767328" y="2715768"/>
+            <a:ext cx="1956816" cy="384048"/>
+          </a:xfrm>
+          <a:prstGeom prst="rect">
+            <a:avLst/>
+          </a:prstGeom>
+          <a:noFill/>
+          <a:ln/>
+        </p:spPr>
+        <p:txBody>
+          <a:bodyPr wrap="square" lIns="0" tIns="0" rIns="0" bIns="0" rtlCol="0" anchor="ctr"/>
+          <a:lstStyle/>
+          <a:p>
+            <a:pPr indent="0" marL="0">
+              <a:buNone/>
+            </a:pPr>
+            <a:r>
+              <a:rPr lang="en-US" sz="1150" b="1" dirty="0">
+                <a:solidFill>
+                  <a:srgbClr val="272E52"/>
+                </a:solidFill>
+                <a:latin typeface="Arial" pitchFamily="34" charset="0"/>
+                <a:ea typeface="Arial" pitchFamily="34" charset="-122"/>
+                <a:cs typeface="Arial" pitchFamily="34" charset="-120"/>
+              </a:rPr>
+              <a:t>Grafana</a:t>
+            </a:r>
+            <a:endParaRPr lang="en-US" sz="1150" dirty="0"/>
+          </a:p>
+        </p:txBody>
+      </p:sp>
+      <p:sp>
+        <p:nvSpPr>
+          <p:cNvPr id="26" name="Shape 18"/>
+          <p:cNvSpPr/>
+          <p:nvPr/>
+        </p:nvSpPr>
+        <p:spPr>
+          <a:xfrm>
+            <a:off x="3291840" y="3200400"/>
+            <a:ext cx="2560320" cy="384048"/>
+          </a:xfrm>
+          <a:prstGeom prst="roundRect">
+            <a:avLst>
+              <a:gd name="adj" fmla="val 11905"/>
+            </a:avLst>
+          </a:prstGeom>
+          <a:solidFill>
+            <a:srgbClr val="F5F6FC"/>
+          </a:solidFill>
+          <a:ln w="9525">
+            <a:solidFill>
+              <a:srgbClr val="DFE3F0"/>
+            </a:solidFill>
+            <a:prstDash val="solid"/>
+          </a:ln>
+        </p:spPr>
+      </p:sp>
+      <p:pic>
+        <p:nvPicPr>
+          <p:cNvPr id="27" name="Image 6" descr="/Users/jacobmenge/Desktop/kurs-unterlagen/folien/assets/icons/kubernetes-326CE5.png">    </p:cNvPr>
+          <p:cNvPicPr>
+            <a:picLocks noChangeAspect="1"/>
+          </p:cNvPicPr>
+          <p:nvPr/>
+        </p:nvPicPr>
+        <p:blipFill>
+          <a:blip r:embed="rId7"/>
+          <a:stretch>
+            <a:fillRect/>
+          </a:stretch>
+        </p:blipFill>
+        <p:spPr>
+          <a:xfrm>
+            <a:off x="3419856" y="3273552"/>
+            <a:ext cx="237744" cy="237744"/>
+          </a:xfrm>
+          <a:prstGeom prst="rect">
+            <a:avLst/>
+          </a:prstGeom>
+        </p:spPr>
+      </p:pic>
+      <p:sp>
+        <p:nvSpPr>
+          <p:cNvPr id="28" name="Text 19"/>
+          <p:cNvSpPr/>
+          <p:nvPr/>
+        </p:nvSpPr>
+        <p:spPr>
+          <a:xfrm>
+            <a:off x="3767328" y="3200400"/>
+            <a:ext cx="1956816" cy="384048"/>
+          </a:xfrm>
+          <a:prstGeom prst="rect">
+            <a:avLst/>
+          </a:prstGeom>
+          <a:noFill/>
+          <a:ln/>
+        </p:spPr>
+        <p:txBody>
+          <a:bodyPr wrap="square" lIns="0" tIns="0" rIns="0" bIns="0" rtlCol="0" anchor="ctr"/>
+          <a:lstStyle/>
+          <a:p>
+            <a:pPr indent="0" marL="0">
+              <a:buNone/>
+            </a:pPr>
+            <a:r>
+              <a:rPr lang="en-US" sz="1150" b="1" dirty="0">
+                <a:solidFill>
+                  <a:srgbClr val="272E52"/>
+                </a:solidFill>
+                <a:latin typeface="Arial" pitchFamily="34" charset="0"/>
+                <a:ea typeface="Arial" pitchFamily="34" charset="-122"/>
+                <a:cs typeface="Arial" pitchFamily="34" charset="-120"/>
+              </a:rPr>
+              <a:t>Kubernetes &amp; Helm</a:t>
+            </a:r>
+            <a:endParaRPr lang="en-US" sz="1150" dirty="0"/>
+          </a:p>
+        </p:txBody>
+      </p:sp>
+      <p:sp>
+        <p:nvSpPr>
+          <p:cNvPr id="29" name="Shape 20"/>
+          <p:cNvSpPr/>
+          <p:nvPr/>
+        </p:nvSpPr>
+        <p:spPr>
+          <a:xfrm>
+            <a:off x="3291840" y="3685032"/>
+            <a:ext cx="2560320" cy="384048"/>
+          </a:xfrm>
+          <a:prstGeom prst="roundRect">
+            <a:avLst>
+              <a:gd name="adj" fmla="val 11905"/>
+            </a:avLst>
+          </a:prstGeom>
+          <a:solidFill>
+            <a:srgbClr val="F5F6FC"/>
+          </a:solidFill>
+          <a:ln w="9525">
+            <a:solidFill>
+              <a:srgbClr val="DFE3F0"/>
+            </a:solidFill>
+            <a:prstDash val="solid"/>
+          </a:ln>
+        </p:spPr>
+      </p:sp>
+      <p:pic>
+        <p:nvPicPr>
+          <p:cNvPr id="30" name="Image 7" descr="/Users/jacobmenge/Desktop/kurs-unterlagen/folien/assets/icons/githubactions-2088FF.png">    </p:cNvPr>
+          <p:cNvPicPr>
+            <a:picLocks noChangeAspect="1"/>
+          </p:cNvPicPr>
+          <p:nvPr/>
+        </p:nvPicPr>
+        <p:blipFill>
+          <a:blip r:embed="rId8"/>
+          <a:stretch>
+            <a:fillRect/>
+          </a:stretch>
+        </p:blipFill>
+        <p:spPr>
+          <a:xfrm>
+            <a:off x="3419856" y="3758184"/>
+            <a:ext cx="237744" cy="237744"/>
+          </a:xfrm>
+          <a:prstGeom prst="rect">
+            <a:avLst/>
+          </a:prstGeom>
+        </p:spPr>
+      </p:pic>
+      <p:sp>
+        <p:nvSpPr>
+          <p:cNvPr id="31" name="Text 21"/>
+          <p:cNvSpPr/>
+          <p:nvPr/>
+        </p:nvSpPr>
+        <p:spPr>
+          <a:xfrm>
+            <a:off x="3767328" y="3685032"/>
+            <a:ext cx="1956816" cy="384048"/>
+          </a:xfrm>
+          <a:prstGeom prst="rect">
+            <a:avLst/>
+          </a:prstGeom>
+          <a:noFill/>
+          <a:ln/>
+        </p:spPr>
+        <p:txBody>
+          <a:bodyPr wrap="square" lIns="0" tIns="0" rIns="0" bIns="0" rtlCol="0" anchor="ctr"/>
+          <a:lstStyle/>
+          <a:p>
+            <a:pPr indent="0" marL="0">
+              <a:buNone/>
+            </a:pPr>
+            <a:r>
+              <a:rPr lang="en-US" sz="1150" b="1" dirty="0">
+                <a:solidFill>
+                  <a:srgbClr val="272E52"/>
+                </a:solidFill>
+                <a:latin typeface="Arial" pitchFamily="34" charset="0"/>
+                <a:ea typeface="Arial" pitchFamily="34" charset="-122"/>
+                <a:cs typeface="Arial" pitchFamily="34" charset="-120"/>
+              </a:rPr>
+              <a:t>Git &amp; GitHub Actions</a:t>
+            </a:r>
+            <a:endParaRPr lang="en-US" sz="1150" dirty="0"/>
+          </a:p>
+        </p:txBody>
+      </p:sp>
+      <p:sp>
+        <p:nvSpPr>
+          <p:cNvPr id="32" name="Text 22"/>
+          <p:cNvSpPr/>
+          <p:nvPr/>
+        </p:nvSpPr>
+        <p:spPr>
+          <a:xfrm>
+            <a:off x="6016752" y="1938528"/>
+            <a:ext cx="2560320" cy="256032"/>
+          </a:xfrm>
+          <a:prstGeom prst="rect">
+            <a:avLst/>
+          </a:prstGeom>
+          <a:noFill/>
+          <a:ln/>
+        </p:spPr>
+        <p:txBody>
+          <a:bodyPr wrap="square" lIns="0" tIns="0" rIns="0" bIns="0" rtlCol="0" anchor="ctr"/>
+          <a:lstStyle/>
+          <a:p>
+            <a:pPr indent="0" marL="0">
+              <a:buNone/>
+            </a:pPr>
+            <a:r>
+              <a:rPr lang="en-US" sz="1100" b="1" dirty="0">
+                <a:solidFill>
+                  <a:srgbClr val="5C6377"/>
+                </a:solidFill>
+                <a:latin typeface="Arial" pitchFamily="34" charset="0"/>
+                <a:ea typeface="Arial" pitchFamily="34" charset="-122"/>
+                <a:cs typeface="Arial" pitchFamily="34" charset="-120"/>
+              </a:rPr>
+              <a:t>Thema 3 · Qualität &amp; Sicherheit</a:t>
+            </a:r>
+            <a:endParaRPr lang="en-US" sz="1100" dirty="0"/>
+          </a:p>
+        </p:txBody>
+      </p:sp>
+      <p:sp>
+        <p:nvSpPr>
+          <p:cNvPr id="33" name="Shape 23"/>
+          <p:cNvSpPr/>
+          <p:nvPr/>
+        </p:nvSpPr>
+        <p:spPr>
+          <a:xfrm>
+            <a:off x="6016752" y="2231136"/>
+            <a:ext cx="2560320" cy="384048"/>
+          </a:xfrm>
+          <a:prstGeom prst="roundRect">
+            <a:avLst>
+              <a:gd name="adj" fmla="val 11905"/>
+            </a:avLst>
+          </a:prstGeom>
+          <a:solidFill>
+            <a:srgbClr val="F5F6FC"/>
+          </a:solidFill>
+          <a:ln w="9525">
+            <a:solidFill>
+              <a:srgbClr val="DFE3F0"/>
+            </a:solidFill>
+            <a:prstDash val="solid"/>
+          </a:ln>
+        </p:spPr>
+      </p:sp>
+      <p:pic>
+        <p:nvPicPr>
+          <p:cNvPr id="34" name="Image 8" descr="/Users/jacobmenge/Desktop/kurs-unterlagen/folien/assets/icons/trivy-1904DA.png">    </p:cNvPr>
+          <p:cNvPicPr>
+            <a:picLocks noChangeAspect="1"/>
+          </p:cNvPicPr>
+          <p:nvPr/>
+        </p:nvPicPr>
+        <p:blipFill>
+          <a:blip r:embed="rId9"/>
+          <a:stretch>
+            <a:fillRect/>
+          </a:stretch>
+        </p:blipFill>
+        <p:spPr>
+          <a:xfrm>
+            <a:off x="6144768" y="2304288"/>
+            <a:ext cx="237744" cy="237744"/>
+          </a:xfrm>
+          <a:prstGeom prst="rect">
+            <a:avLst/>
+          </a:prstGeom>
+        </p:spPr>
+      </p:pic>
+      <p:sp>
+        <p:nvSpPr>
+          <p:cNvPr id="35" name="Text 24"/>
+          <p:cNvSpPr/>
+          <p:nvPr/>
+        </p:nvSpPr>
+        <p:spPr>
+          <a:xfrm>
+            <a:off x="6492240" y="2231136"/>
+            <a:ext cx="1956816" cy="384048"/>
+          </a:xfrm>
+          <a:prstGeom prst="rect">
+            <a:avLst/>
+          </a:prstGeom>
+          <a:noFill/>
+          <a:ln/>
+        </p:spPr>
+        <p:txBody>
+          <a:bodyPr wrap="square" lIns="0" tIns="0" rIns="0" bIns="0" rtlCol="0" anchor="ctr"/>
+          <a:lstStyle/>
+          <a:p>
+            <a:pPr indent="0" marL="0">
+              <a:buNone/>
+            </a:pPr>
+            <a:r>
+              <a:rPr lang="en-US" sz="1150" b="1" dirty="0">
+                <a:solidFill>
+                  <a:srgbClr val="272E52"/>
+                </a:solidFill>
+                <a:latin typeface="Arial" pitchFamily="34" charset="0"/>
+                <a:ea typeface="Arial" pitchFamily="34" charset="-122"/>
+                <a:cs typeface="Arial" pitchFamily="34" charset="-120"/>
+              </a:rPr>
+              <a:t>Trivy Image-Scanner</a:t>
+            </a:r>
+            <a:endParaRPr lang="en-US" sz="1150" dirty="0"/>
+          </a:p>
+        </p:txBody>
+      </p:sp>
+      <p:sp>
+        <p:nvSpPr>
+          <p:cNvPr id="36" name="Shape 25"/>
+          <p:cNvSpPr/>
+          <p:nvPr/>
+        </p:nvSpPr>
+        <p:spPr>
+          <a:xfrm>
+            <a:off x="6016752" y="2715768"/>
+            <a:ext cx="2560320" cy="384048"/>
+          </a:xfrm>
+          <a:prstGeom prst="roundRect">
+            <a:avLst>
+              <a:gd name="adj" fmla="val 11905"/>
+            </a:avLst>
+          </a:prstGeom>
+          <a:solidFill>
+            <a:srgbClr val="F5F6FC"/>
+          </a:solidFill>
+          <a:ln w="9525">
+            <a:solidFill>
+              <a:srgbClr val="DFE3F0"/>
+            </a:solidFill>
+            <a:prstDash val="solid"/>
+          </a:ln>
+        </p:spPr>
+      </p:sp>
+      <p:sp>
+        <p:nvSpPr>
+          <p:cNvPr id="37" name="Text 26"/>
+          <p:cNvSpPr/>
+          <p:nvPr/>
+        </p:nvSpPr>
+        <p:spPr>
+          <a:xfrm>
+            <a:off x="6181344" y="2715768"/>
+            <a:ext cx="2304288" cy="384048"/>
+          </a:xfrm>
+          <a:prstGeom prst="rect">
+            <a:avLst/>
+          </a:prstGeom>
+          <a:noFill/>
+          <a:ln/>
+        </p:spPr>
+        <p:txBody>
+          <a:bodyPr wrap="square" lIns="0" tIns="0" rIns="0" bIns="0" rtlCol="0" anchor="ctr"/>
+          <a:lstStyle/>
+          <a:p>
+            <a:pPr indent="0" marL="0">
+              <a:buNone/>
+            </a:pPr>
+            <a:r>
+              <a:rPr lang="en-US" sz="1150" b="1" dirty="0">
+                <a:solidFill>
+                  <a:srgbClr val="272E52"/>
+                </a:solidFill>
+                <a:latin typeface="Arial" pitchFamily="34" charset="0"/>
+                <a:ea typeface="Arial" pitchFamily="34" charset="-122"/>
+                <a:cs typeface="Arial" pitchFamily="34" charset="-120"/>
+              </a:rPr>
+              <a:t>Testverfahren &amp; Testpläne</a:t>
+            </a:r>
+            <a:endParaRPr lang="en-US" sz="1150" dirty="0"/>
+          </a:p>
+        </p:txBody>
+      </p:sp>
+      <p:sp>
+        <p:nvSpPr>
+          <p:cNvPr id="38" name="Shape 27"/>
+          <p:cNvSpPr/>
+          <p:nvPr/>
+        </p:nvSpPr>
+        <p:spPr>
+          <a:xfrm>
+            <a:off x="6016752" y="3200400"/>
+            <a:ext cx="2560320" cy="384048"/>
+          </a:xfrm>
+          <a:prstGeom prst="roundRect">
+            <a:avLst>
+              <a:gd name="adj" fmla="val 11905"/>
+            </a:avLst>
+          </a:prstGeom>
+          <a:solidFill>
+            <a:srgbClr val="F5F6FC"/>
+          </a:solidFill>
+          <a:ln w="9525">
+            <a:solidFill>
+              <a:srgbClr val="DFE3F0"/>
+            </a:solidFill>
+            <a:prstDash val="solid"/>
+          </a:ln>
+        </p:spPr>
+      </p:sp>
+      <p:sp>
+        <p:nvSpPr>
+          <p:cNvPr id="39" name="Text 28"/>
+          <p:cNvSpPr/>
+          <p:nvPr/>
+        </p:nvSpPr>
+        <p:spPr>
+          <a:xfrm>
+            <a:off x="6181344" y="3200400"/>
+            <a:ext cx="2304288" cy="384048"/>
+          </a:xfrm>
+          <a:prstGeom prst="rect">
+            <a:avLst/>
+          </a:prstGeom>
+          <a:noFill/>
+          <a:ln/>
+        </p:spPr>
+        <p:txBody>
+          <a:bodyPr wrap="square" lIns="0" tIns="0" rIns="0" bIns="0" rtlCol="0" anchor="ctr"/>
+          <a:lstStyle/>
+          <a:p>
+            <a:pPr indent="0" marL="0">
+              <a:buNone/>
+            </a:pPr>
+            <a:r>
+              <a:rPr lang="en-US" sz="1150" b="1" dirty="0">
+                <a:solidFill>
+                  <a:srgbClr val="272E52"/>
+                </a:solidFill>
+                <a:latin typeface="Arial" pitchFamily="34" charset="0"/>
+                <a:ea typeface="Arial" pitchFamily="34" charset="-122"/>
+                <a:cs typeface="Arial" pitchFamily="34" charset="-120"/>
+              </a:rPr>
+              <a:t>Risikoanalyse</a:t>
+            </a:r>
+            <a:endParaRPr lang="en-US" sz="1150" dirty="0"/>
+          </a:p>
+        </p:txBody>
+      </p:sp>
+      <p:sp>
+        <p:nvSpPr>
+          <p:cNvPr id="40" name="Shape 29"/>
+          <p:cNvSpPr/>
+          <p:nvPr/>
+        </p:nvSpPr>
+        <p:spPr>
+          <a:xfrm>
+            <a:off x="6016752" y="3685032"/>
+            <a:ext cx="2560320" cy="384048"/>
+          </a:xfrm>
+          <a:prstGeom prst="roundRect">
+            <a:avLst>
+              <a:gd name="adj" fmla="val 11905"/>
+            </a:avLst>
+          </a:prstGeom>
+          <a:solidFill>
+            <a:srgbClr val="F5F6FC"/>
+          </a:solidFill>
+          <a:ln w="9525">
+            <a:solidFill>
+              <a:srgbClr val="DFE3F0"/>
+            </a:solidFill>
+            <a:prstDash val="solid"/>
+          </a:ln>
+        </p:spPr>
+      </p:sp>
+      <p:sp>
+        <p:nvSpPr>
+          <p:cNvPr id="41" name="Text 30"/>
+          <p:cNvSpPr/>
+          <p:nvPr/>
+        </p:nvSpPr>
+        <p:spPr>
+          <a:xfrm>
+            <a:off x="6181344" y="3685032"/>
+            <a:ext cx="2304288" cy="384048"/>
+          </a:xfrm>
+          <a:prstGeom prst="rect">
+            <a:avLst/>
+          </a:prstGeom>
+          <a:noFill/>
+          <a:ln/>
+        </p:spPr>
+        <p:txBody>
+          <a:bodyPr wrap="square" lIns="0" tIns="0" rIns="0" bIns="0" rtlCol="0" anchor="ctr"/>
+          <a:lstStyle/>
+          <a:p>
+            <a:pPr indent="0" marL="0">
+              <a:buNone/>
+            </a:pPr>
+            <a:r>
+              <a:rPr lang="en-US" sz="1150" b="1" dirty="0">
+                <a:solidFill>
+                  <a:srgbClr val="272E52"/>
+                </a:solidFill>
+                <a:latin typeface="Arial" pitchFamily="34" charset="0"/>
+                <a:ea typeface="Arial" pitchFamily="34" charset="-122"/>
+                <a:cs typeface="Arial" pitchFamily="34" charset="-120"/>
+              </a:rPr>
+              <a:t>Fallübungen &amp; Simulationen</a:t>
+            </a:r>
+            <a:endParaRPr lang="en-US" sz="1150" dirty="0"/>
+          </a:p>
+        </p:txBody>
+      </p:sp>
+      <p:sp>
+        <p:nvSpPr>
+          <p:cNvPr id="42" name="Shape 31"/>
+          <p:cNvSpPr/>
+          <p:nvPr/>
+        </p:nvSpPr>
+        <p:spPr>
+          <a:xfrm>
+            <a:off x="566928" y="4288536"/>
+            <a:ext cx="32004" cy="256032"/>
+          </a:xfrm>
+          <a:prstGeom prst="rect">
+            <a:avLst/>
+          </a:prstGeom>
+          <a:solidFill>
+            <a:srgbClr val="3843AF"/>
+          </a:solidFill>
+          <a:ln/>
+        </p:spPr>
+      </p:sp>
+      <p:sp>
+        <p:nvSpPr>
+          <p:cNvPr id="43" name="Text 32"/>
+          <p:cNvSpPr/>
+          <p:nvPr/>
+        </p:nvSpPr>
+        <p:spPr>
+          <a:xfrm>
+            <a:off x="749808" y="4242816"/>
+            <a:ext cx="7827264" cy="402336"/>
+          </a:xfrm>
+          <a:prstGeom prst="rect">
+            <a:avLst/>
+          </a:prstGeom>
+          <a:noFill/>
+          <a:ln/>
+        </p:spPr>
+        <p:txBody>
+          <a:bodyPr wrap="square" lIns="0" tIns="0" rIns="0" bIns="0" rtlCol="0" anchor="ctr"/>
+          <a:lstStyle/>
+          <a:p>
+            <a:pPr indent="0" marL="0">
+              <a:buNone/>
+            </a:pPr>
+            <a:r>
+              <a:rPr lang="en-US" sz="1200" b="1" dirty="0">
+                <a:solidFill>
+                  <a:srgbClr val="434A63"/>
+                </a:solidFill>
+                <a:latin typeface="Arial" pitchFamily="34" charset="0"/>
+                <a:ea typeface="Arial" pitchFamily="34" charset="-122"/>
+                <a:cs typeface="Arial" pitchFamily="34" charset="-120"/>
+              </a:rPr>
+              <a:t>Alles wird gemeinsam installiert – bringt nur euren Rechner mit.</a:t>
+            </a:r>
+            <a:endParaRPr lang="en-US" sz="1200" dirty="0"/>
+          </a:p>
+        </p:txBody>
+      </p:sp>
+      <p:sp>
+        <p:nvSpPr>
+          <p:cNvPr id="44" name="Shape 33"/>
+          <p:cNvSpPr/>
+          <p:nvPr/>
+        </p:nvSpPr>
+        <p:spPr>
+          <a:xfrm>
+            <a:off x="566928" y="4631436"/>
+            <a:ext cx="8010144" cy="0"/>
+          </a:xfrm>
+          <a:prstGeom prst="line">
+            <a:avLst/>
+          </a:prstGeom>
+          <a:noFill/>
+          <a:ln w="9525">
+            <a:solidFill>
+              <a:srgbClr val="DFE3F0"/>
+            </a:solidFill>
+            <a:prstDash val="solid"/>
+          </a:ln>
+        </p:spPr>
+      </p:sp>
+      <p:sp>
+        <p:nvSpPr>
+          <p:cNvPr id="45" name="Text 34"/>
           <p:cNvSpPr/>
           <p:nvPr/>
         </p:nvSpPr>
@@ -6923,7 +7376,7 @@
       </p:sp>
       <p:sp>
         <p:nvSpPr>
-          <p:cNvPr id="25" name="Text 23"/>
+          <p:cNvPr id="46" name="Text 35"/>
           <p:cNvSpPr/>
           <p:nvPr/>
         </p:nvSpPr>
@@ -7169,9 +7622,33 @@
           <a:ln/>
         </p:spPr>
       </p:sp>
-      <p:sp>
-        <p:nvSpPr>
-          <p:cNvPr id="8" name="Text 6"/>
+      <p:pic>
+        <p:nvPicPr>
+          <p:cNvPr id="8" name="Image 0" descr="/Users/jacobmenge/Desktop/kurs-unterlagen/folien/assets/icons/pluralsight-F15B2A.png">    </p:cNvPr>
+          <p:cNvPicPr>
+            <a:picLocks noChangeAspect="1"/>
+          </p:cNvPicPr>
+          <p:nvPr/>
+        </p:nvPicPr>
+        <p:blipFill>
+          <a:blip r:embed="rId1"/>
+          <a:stretch>
+            <a:fillRect/>
+          </a:stretch>
+        </p:blipFill>
+        <p:spPr>
+          <a:xfrm>
+            <a:off x="4041648" y="2103120"/>
+            <a:ext cx="274320" cy="274320"/>
+          </a:xfrm>
+          <a:prstGeom prst="rect">
+            <a:avLst/>
+          </a:prstGeom>
+        </p:spPr>
+      </p:pic>
+      <p:sp>
+        <p:nvSpPr>
+          <p:cNvPr id="9" name="Text 6"/>
           <p:cNvSpPr/>
           <p:nvPr/>
         </p:nvSpPr>
@@ -7210,7 +7687,7 @@
       </p:sp>
       <p:sp>
         <p:nvSpPr>
-          <p:cNvPr id="9" name="Text 7"/>
+          <p:cNvPr id="10" name="Text 7"/>
           <p:cNvSpPr/>
           <p:nvPr/>
         </p:nvSpPr>
@@ -7290,7 +7767,7 @@
       </p:sp>
       <p:sp>
         <p:nvSpPr>
-          <p:cNvPr id="10" name="Shape 8"/>
+          <p:cNvPr id="11" name="Shape 8"/>
           <p:cNvSpPr/>
           <p:nvPr/>
         </p:nvSpPr>
@@ -7310,7 +7787,7 @@
       </p:sp>
       <p:sp>
         <p:nvSpPr>
-          <p:cNvPr id="11" name="Shape 9"/>
+          <p:cNvPr id="12" name="Shape 9"/>
           <p:cNvSpPr/>
           <p:nvPr/>
         </p:nvSpPr>
@@ -7330,7 +7807,7 @@
       </p:sp>
       <p:sp>
         <p:nvSpPr>
-          <p:cNvPr id="12" name="Text 10"/>
+          <p:cNvPr id="13" name="Text 10"/>
           <p:cNvSpPr/>
           <p:nvPr/>
         </p:nvSpPr>
@@ -7369,7 +7846,7 @@
       </p:sp>
       <p:sp>
         <p:nvSpPr>
-          <p:cNvPr id="13" name="Text 11"/>
+          <p:cNvPr id="14" name="Text 11"/>
           <p:cNvSpPr/>
           <p:nvPr/>
         </p:nvSpPr>
@@ -7449,7 +7926,7 @@
       </p:sp>
       <p:sp>
         <p:nvSpPr>
-          <p:cNvPr id="14" name="Shape 12"/>
+          <p:cNvPr id="15" name="Shape 12"/>
           <p:cNvSpPr/>
           <p:nvPr/>
         </p:nvSpPr>
@@ -7469,7 +7946,7 @@
       </p:sp>
       <p:sp>
         <p:nvSpPr>
-          <p:cNvPr id="15" name="Text 13"/>
+          <p:cNvPr id="16" name="Text 13"/>
           <p:cNvSpPr/>
           <p:nvPr/>
         </p:nvSpPr>
@@ -7508,7 +7985,7 @@
       </p:sp>
       <p:sp>
         <p:nvSpPr>
-          <p:cNvPr id="16" name="Shape 14"/>
+          <p:cNvPr id="17" name="Shape 14"/>
           <p:cNvSpPr/>
           <p:nvPr/>
         </p:nvSpPr>
@@ -7531,7 +8008,7 @@
       </p:sp>
       <p:sp>
         <p:nvSpPr>
-          <p:cNvPr id="17" name="Text 15"/>
+          <p:cNvPr id="18" name="Text 15"/>
           <p:cNvSpPr/>
           <p:nvPr/>
         </p:nvSpPr>
@@ -7570,7 +8047,7 @@
       </p:sp>
       <p:sp>
         <p:nvSpPr>
-          <p:cNvPr id="18" name="Text 16"/>
+          <p:cNvPr id="19" name="Text 16"/>
           <p:cNvSpPr/>
           <p:nvPr/>
         </p:nvSpPr>
@@ -10131,9 +10608,33 @@
           <a:ln/>
         </p:spPr>
       </p:sp>
-      <p:sp>
-        <p:nvSpPr>
-          <p:cNvPr id="8" name="Text 6"/>
+      <p:pic>
+        <p:nvPicPr>
+          <p:cNvPr id="8" name="Image 0" descr="/Users/jacobmenge/Desktop/kurs-unterlagen/folien/assets/icons/googlemeet-00897B.png">    </p:cNvPr>
+          <p:cNvPicPr>
+            <a:picLocks noChangeAspect="1"/>
+          </p:cNvPicPr>
+          <p:nvPr/>
+        </p:nvPicPr>
+        <p:blipFill>
+          <a:blip r:embed="rId1"/>
+          <a:stretch>
+            <a:fillRect/>
+          </a:stretch>
+        </p:blipFill>
+        <p:spPr>
+          <a:xfrm>
+            <a:off x="8211312" y="4041648"/>
+            <a:ext cx="219456" cy="219456"/>
+          </a:xfrm>
+          <a:prstGeom prst="rect">
+            <a:avLst/>
+          </a:prstGeom>
+        </p:spPr>
+      </p:pic>
+      <p:sp>
+        <p:nvSpPr>
+          <p:cNvPr id="9" name="Text 6"/>
           <p:cNvSpPr/>
           <p:nvPr/>
         </p:nvSpPr>
@@ -10175,7 +10676,7 @@
       </p:sp>
       <p:sp>
         <p:nvSpPr>
-          <p:cNvPr id="9" name="Shape 7"/>
+          <p:cNvPr id="10" name="Shape 7"/>
           <p:cNvSpPr/>
           <p:nvPr/>
         </p:nvSpPr>
@@ -10198,7 +10699,7 @@
       </p:sp>
       <p:sp>
         <p:nvSpPr>
-          <p:cNvPr id="10" name="Text 8"/>
+          <p:cNvPr id="11" name="Text 8"/>
           <p:cNvSpPr/>
           <p:nvPr/>
         </p:nvSpPr>
@@ -10237,7 +10738,7 @@
       </p:sp>
       <p:sp>
         <p:nvSpPr>
-          <p:cNvPr id="11" name="Text 9"/>
+          <p:cNvPr id="12" name="Text 9"/>
           <p:cNvSpPr/>
           <p:nvPr/>
         </p:nvSpPr>
@@ -12416,9 +12917,33 @@
           <a:ln/>
         </p:spPr>
       </p:sp>
-      <p:sp>
-        <p:nvSpPr>
-          <p:cNvPr id="17" name="Text 15"/>
+      <p:pic>
+        <p:nvPicPr>
+          <p:cNvPr id="17" name="Image 0" descr="/Users/jacobmenge/Desktop/kurs-unterlagen/folien/assets/icons/cloudhelden.png">    </p:cNvPr>
+          <p:cNvPicPr>
+            <a:picLocks noChangeAspect="1"/>
+          </p:cNvPicPr>
+          <p:nvPr/>
+        </p:nvPicPr>
+        <p:blipFill>
+          <a:blip r:embed="rId1"/>
+          <a:stretch>
+            <a:fillRect/>
+          </a:stretch>
+        </p:blipFill>
+        <p:spPr>
+          <a:xfrm>
+            <a:off x="6099048" y="1700784"/>
+            <a:ext cx="274320" cy="274320"/>
+          </a:xfrm>
+          <a:prstGeom prst="rect">
+            <a:avLst/>
+          </a:prstGeom>
+        </p:spPr>
+      </p:pic>
+      <p:sp>
+        <p:nvSpPr>
+          <p:cNvPr id="18" name="Text 15"/>
           <p:cNvSpPr/>
           <p:nvPr/>
         </p:nvSpPr>
@@ -12457,7 +12982,7 @@
       </p:sp>
       <p:sp>
         <p:nvSpPr>
-          <p:cNvPr id="18" name="Text 16"/>
+          <p:cNvPr id="19" name="Text 16"/>
           <p:cNvSpPr/>
           <p:nvPr/>
         </p:nvSpPr>
@@ -12496,7 +13021,7 @@
       </p:sp>
       <p:sp>
         <p:nvSpPr>
-          <p:cNvPr id="19" name="Text 17"/>
+          <p:cNvPr id="20" name="Text 17"/>
           <p:cNvSpPr/>
           <p:nvPr/>
         </p:nvSpPr>
@@ -12538,7 +13063,7 @@
       </p:sp>
       <p:sp>
         <p:nvSpPr>
-          <p:cNvPr id="20" name="Shape 18"/>
+          <p:cNvPr id="21" name="Shape 18"/>
           <p:cNvSpPr/>
           <p:nvPr/>
         </p:nvSpPr>
@@ -12558,7 +13083,7 @@
       </p:sp>
       <p:sp>
         <p:nvSpPr>
-          <p:cNvPr id="21" name="Shape 19"/>
+          <p:cNvPr id="22" name="Shape 19"/>
           <p:cNvSpPr/>
           <p:nvPr/>
         </p:nvSpPr>
@@ -12576,9 +13101,33 @@
           <a:ln/>
         </p:spPr>
       </p:sp>
-      <p:sp>
-        <p:nvSpPr>
-          <p:cNvPr id="22" name="Text 20"/>
+      <p:pic>
+        <p:nvPicPr>
+          <p:cNvPr id="23" name="Image 1" descr="/Users/jacobmenge/Desktop/kurs-unterlagen/folien/assets/icons/pluralsight-F15B2A.png">    </p:cNvPr>
+          <p:cNvPicPr>
+            <a:picLocks noChangeAspect="1"/>
+          </p:cNvPicPr>
+          <p:nvPr/>
+        </p:nvPicPr>
+        <p:blipFill>
+          <a:blip r:embed="rId2"/>
+          <a:stretch>
+            <a:fillRect/>
+          </a:stretch>
+        </p:blipFill>
+        <p:spPr>
+          <a:xfrm>
+            <a:off x="8156448" y="1700784"/>
+            <a:ext cx="274320" cy="274320"/>
+          </a:xfrm>
+          <a:prstGeom prst="rect">
+            <a:avLst/>
+          </a:prstGeom>
+        </p:spPr>
+      </p:pic>
+      <p:sp>
+        <p:nvSpPr>
+          <p:cNvPr id="24" name="Text 20"/>
           <p:cNvSpPr/>
           <p:nvPr/>
         </p:nvSpPr>
@@ -12617,7 +13166,7 @@
       </p:sp>
       <p:sp>
         <p:nvSpPr>
-          <p:cNvPr id="23" name="Text 21"/>
+          <p:cNvPr id="25" name="Text 21"/>
           <p:cNvSpPr/>
           <p:nvPr/>
         </p:nvSpPr>
@@ -12656,7 +13205,7 @@
       </p:sp>
       <p:sp>
         <p:nvSpPr>
-          <p:cNvPr id="24" name="Text 22"/>
+          <p:cNvPr id="26" name="Text 22"/>
           <p:cNvSpPr/>
           <p:nvPr/>
         </p:nvSpPr>
@@ -12698,7 +13247,7 @@
       </p:sp>
       <p:sp>
         <p:nvSpPr>
-          <p:cNvPr id="25" name="Shape 23"/>
+          <p:cNvPr id="27" name="Shape 23"/>
           <p:cNvSpPr/>
           <p:nvPr/>
         </p:nvSpPr>
@@ -12718,7 +13267,7 @@
       </p:sp>
       <p:sp>
         <p:nvSpPr>
-          <p:cNvPr id="26" name="Text 24"/>
+          <p:cNvPr id="28" name="Text 24"/>
           <p:cNvSpPr/>
           <p:nvPr/>
         </p:nvSpPr>
@@ -12757,7 +13306,7 @@
       </p:sp>
       <p:sp>
         <p:nvSpPr>
-          <p:cNvPr id="27" name="Shape 25"/>
+          <p:cNvPr id="29" name="Shape 25"/>
           <p:cNvSpPr/>
           <p:nvPr/>
         </p:nvSpPr>
@@ -12780,7 +13329,7 @@
       </p:sp>
       <p:sp>
         <p:nvSpPr>
-          <p:cNvPr id="28" name="Text 26"/>
+          <p:cNvPr id="30" name="Text 26"/>
           <p:cNvSpPr/>
           <p:nvPr/>
         </p:nvSpPr>
@@ -12819,7 +13368,7 @@
       </p:sp>
       <p:sp>
         <p:nvSpPr>
-          <p:cNvPr id="29" name="Text 27"/>
+          <p:cNvPr id="31" name="Text 27"/>
           <p:cNvSpPr/>
           <p:nvPr/>
         </p:nvSpPr>

</xml_diff>

<commit_message>
folien: an akademie-inhalte angeglichen (terraform, iot, probeklausuren, akademie-beschreibung)
</commit_message>
<xml_diff>
--- a/folien/dist/00-orientierung.pptx
+++ b/folien/dist/00-orientierung.pptx
@@ -6196,7 +6196,7 @@
       </p:sp>
       <p:pic>
         <p:nvPicPr>
-          <p:cNvPr id="8" name="Image 0" descr="/Users/jacobmenge/Desktop/kurs-unterlagen/folien/assets/icons/ubuntu-E95420.png">    </p:cNvPr>
+          <p:cNvPr id="8" name="Image 0" descr="/Users/jacobmenge/Desktop/kurs-unterlagen/folien/assets/icons/wireshark-1679A7.png">    </p:cNvPr>
           <p:cNvPicPr>
             <a:picLocks noChangeAspect="1"/>
           </p:cNvPicPr>
@@ -6251,7 +6251,7 @@
                 <a:ea typeface="Arial" pitchFamily="34" charset="-122"/>
                 <a:cs typeface="Arial" pitchFamily="34" charset="-120"/>
               </a:rPr>
-              <a:t>Ubuntu Linux</a:t>
+              <a:t>Netzwerk-Werkzeuge</a:t>
             </a:r>
             <a:endParaRPr lang="en-US" sz="1150" dirty="0"/>
           </a:p>
@@ -6286,7 +6286,7 @@
       </p:sp>
       <p:pic>
         <p:nvPicPr>
-          <p:cNvPr id="11" name="Image 1" descr="/Users/jacobmenge/Desktop/kurs-unterlagen/folien/assets/icons/canonical-E95420.png">    </p:cNvPr>
+          <p:cNvPr id="11" name="Image 1" descr="/Users/jacobmenge/Desktop/kurs-unterlagen/folien/assets/icons/ubuntu-E95420.png">    </p:cNvPr>
           <p:cNvPicPr>
             <a:picLocks noChangeAspect="1"/>
           </p:cNvPicPr>
@@ -6341,7 +6341,7 @@
                 <a:ea typeface="Arial" pitchFamily="34" charset="-122"/>
                 <a:cs typeface="Arial" pitchFamily="34" charset="-120"/>
               </a:rPr>
-              <a:t>Multipass</a:t>
+              <a:t>Linux &amp; Multipass</a:t>
             </a:r>
             <a:endParaRPr lang="en-US" sz="1150" dirty="0"/>
           </a:p>
@@ -6466,7 +6466,7 @@
       </p:sp>
       <p:pic>
         <p:nvPicPr>
-          <p:cNvPr id="17" name="Image 3" descr="/Users/jacobmenge/Desktop/kurs-unterlagen/folien/assets/icons/wireshark-1679A7.png">    </p:cNvPr>
+          <p:cNvPr id="17" name="Image 3" descr="/Users/jacobmenge/Desktop/kurs-unterlagen/folien/assets/icons/mqtt-660066.png">    </p:cNvPr>
           <p:cNvPicPr>
             <a:picLocks noChangeAspect="1"/>
           </p:cNvPicPr>
@@ -6521,7 +6521,7 @@
                 <a:ea typeface="Arial" pitchFamily="34" charset="-122"/>
                 <a:cs typeface="Arial" pitchFamily="34" charset="-120"/>
               </a:rPr>
-              <a:t>Netzwerk-Werkzeuge</a:t>
+              <a:t>MQTT &amp; IoT-Protokolle</a:t>
             </a:r>
             <a:endParaRPr lang="en-US" sz="1150" dirty="0"/>
           </a:p>
@@ -6595,7 +6595,7 @@
       </p:sp>
       <p:pic>
         <p:nvPicPr>
-          <p:cNvPr id="21" name="Image 4" descr="/Users/jacobmenge/Desktop/kurs-unterlagen/folien/assets/icons/prometheus-E6522C.png">    </p:cNvPr>
+          <p:cNvPr id="21" name="Image 4" descr="/Users/jacobmenge/Desktop/kurs-unterlagen/folien/assets/icons/kubernetes-326CE5.png">    </p:cNvPr>
           <p:cNvPicPr>
             <a:picLocks noChangeAspect="1"/>
           </p:cNvPicPr>
@@ -6650,7 +6650,7 @@
                 <a:ea typeface="Arial" pitchFamily="34" charset="-122"/>
                 <a:cs typeface="Arial" pitchFamily="34" charset="-120"/>
               </a:rPr>
-              <a:t>Prometheus</a:t>
+              <a:t>Kubernetes &amp; Helm</a:t>
             </a:r>
             <a:endParaRPr lang="en-US" sz="1150" dirty="0"/>
           </a:p>
@@ -6685,7 +6685,7 @@
       </p:sp>
       <p:pic>
         <p:nvPicPr>
-          <p:cNvPr id="24" name="Image 5" descr="/Users/jacobmenge/Desktop/kurs-unterlagen/folien/assets/icons/grafana-F46800.png">    </p:cNvPr>
+          <p:cNvPr id="24" name="Image 5" descr="/Users/jacobmenge/Desktop/kurs-unterlagen/folien/assets/icons/terraform-844FBA.png">    </p:cNvPr>
           <p:cNvPicPr>
             <a:picLocks noChangeAspect="1"/>
           </p:cNvPicPr>
@@ -6740,7 +6740,7 @@
                 <a:ea typeface="Arial" pitchFamily="34" charset="-122"/>
                 <a:cs typeface="Arial" pitchFamily="34" charset="-120"/>
               </a:rPr>
-              <a:t>Grafana</a:t>
+              <a:t>Terraform</a:t>
             </a:r>
             <a:endParaRPr lang="en-US" sz="1150" dirty="0"/>
           </a:p>
@@ -6775,7 +6775,7 @@
       </p:sp>
       <p:pic>
         <p:nvPicPr>
-          <p:cNvPr id="27" name="Image 6" descr="/Users/jacobmenge/Desktop/kurs-unterlagen/folien/assets/icons/kubernetes-326CE5.png">    </p:cNvPr>
+          <p:cNvPr id="27" name="Image 6" descr="/Users/jacobmenge/Desktop/kurs-unterlagen/folien/assets/icons/grafana-F46800.png">    </p:cNvPr>
           <p:cNvPicPr>
             <a:picLocks noChangeAspect="1"/>
           </p:cNvPicPr>
@@ -6830,7 +6830,7 @@
                 <a:ea typeface="Arial" pitchFamily="34" charset="-122"/>
                 <a:cs typeface="Arial" pitchFamily="34" charset="-120"/>
               </a:rPr>
-              <a:t>Kubernetes &amp; Helm</a:t>
+              <a:t>Prometheus &amp; Grafana</a:t>
             </a:r>
             <a:endParaRPr lang="en-US" sz="1150" dirty="0"/>
           </a:p>
@@ -7306,7 +7306,7 @@
                 <a:ea typeface="Arial" pitchFamily="34" charset="-122"/>
                 <a:cs typeface="Arial" pitchFamily="34" charset="-120"/>
               </a:rPr>
-              <a:t>Alles wird gemeinsam installiert – bringt nur euren Rechner mit.</a:t>
+              <a:t>Dazu AWS-Cloud-Übungen über euren Pluralsight-Zugang. Alles wird gemeinsam eingerichtet.</a:t>
             </a:r>
             <a:endParaRPr lang="en-US" sz="1200" dirty="0"/>
           </a:p>
@@ -10402,7 +10402,7 @@
                 <a:ea typeface="Arial" pitchFamily="34" charset="-122"/>
                 <a:cs typeface="Arial" pitchFamily="34" charset="-120"/>
               </a:rPr>
-              <a:t>Live über Google Meet, zweimal pro Woche am Abend.</a:t>
+              <a:t>Live über Google Meet – den Link findet ihr im Kursdashboard der Akademie.</a:t>
             </a:r>
             <a:endParaRPr lang="en-US" sz="1400" dirty="0"/>
           </a:p>
@@ -13055,7 +13055,7 @@
                 <a:ea typeface="Arial" pitchFamily="34" charset="-122"/>
                 <a:cs typeface="Arial" pitchFamily="34" charset="-120"/>
               </a:rPr>
-              <a:t>Die Lernplattform von Cloudhelden mit zusätzlichem Material.</a:t>
+              <a:t>Lernmodule zum Selbstlernen mit Quiz und Labs – plus alle Foliensätze und Probeklausuren.</a:t>
             </a:r>
             <a:endParaRPr lang="en-US" sz="1050" dirty="0"/>
           </a:p>

</xml_diff>

<commit_message>
folien: auf akademie als zentrale plattform umgestellt
</commit_message>
<xml_diff>
--- a/folien/dist/00-orientierung.pptx
+++ b/folien/dist/00-orientierung.pptx
@@ -12566,7 +12566,7 @@
         <p:spPr>
           <a:xfrm>
             <a:off x="566928" y="1572768"/>
-            <a:ext cx="1837944" cy="2194560"/>
+            <a:ext cx="2523744" cy="2148840"/>
           </a:xfrm>
           <a:prstGeom prst="rect">
             <a:avLst/>
@@ -12586,7 +12586,7 @@
         <p:spPr>
           <a:xfrm>
             <a:off x="566928" y="1572768"/>
-            <a:ext cx="41148" cy="2194560"/>
+            <a:ext cx="41148" cy="2148840"/>
           </a:xfrm>
           <a:prstGeom prst="rect">
             <a:avLst/>
@@ -12645,7 +12645,7 @@
         <p:spPr>
           <a:xfrm>
             <a:off x="1298448" y="1719072"/>
-            <a:ext cx="941832" cy="420624"/>
+            <a:ext cx="1627632" cy="292608"/>
           </a:xfrm>
           <a:prstGeom prst="rect">
             <a:avLst/>
@@ -12661,7 +12661,7 @@
               <a:buNone/>
             </a:pPr>
             <a:r>
-              <a:rPr lang="en-US" sz="1200" b="1" dirty="0">
+              <a:rPr lang="en-US" sz="1250" b="1" dirty="0">
                 <a:solidFill>
                   <a:srgbClr val="272E52"/>
                 </a:solidFill>
@@ -12671,7 +12671,7 @@
               </a:rPr>
               <a:t>Die Folien</a:t>
             </a:r>
-            <a:endParaRPr lang="en-US" sz="1200" dirty="0"/>
+            <a:endParaRPr lang="en-US" sz="1250" dirty="0"/>
           </a:p>
         </p:txBody>
       </p:sp>
@@ -12683,8 +12683,8 @@
         </p:nvSpPr>
         <p:spPr>
           <a:xfrm>
-            <a:off x="1298448" y="2185416"/>
-            <a:ext cx="941832" cy="1463040"/>
+            <a:off x="1298448" y="2057400"/>
+            <a:ext cx="1627632" cy="1545336"/>
           </a:xfrm>
           <a:prstGeom prst="rect">
             <a:avLst/>
@@ -12703,7 +12703,7 @@
               <a:buNone/>
             </a:pPr>
             <a:r>
-              <a:rPr lang="en-US" sz="1050" dirty="0">
+              <a:rPr lang="en-US" sz="1100" dirty="0">
                 <a:solidFill>
                   <a:srgbClr val="434A63"/>
                 </a:solidFill>
@@ -12711,9 +12711,9 @@
                 <a:ea typeface="Arial" pitchFamily="34" charset="-122"/>
                 <a:cs typeface="Arial" pitchFamily="34" charset="-120"/>
               </a:rPr>
-              <a:t>Führen durch den Abend, zum Nacharbeiten.</a:t>
-            </a:r>
-            <a:endParaRPr lang="en-US" sz="1050" dirty="0"/>
+              <a:t>Führen durch den Kursabend – ihr findet sie danach in der Akademie zum Nacharbeiten.</a:t>
+            </a:r>
+            <a:endParaRPr lang="en-US" sz="1100" dirty="0"/>
           </a:p>
         </p:txBody>
       </p:sp>
@@ -12725,8 +12725,8 @@
         </p:nvSpPr>
         <p:spPr>
           <a:xfrm>
-            <a:off x="2624328" y="1572768"/>
-            <a:ext cx="1837944" cy="2194560"/>
+            <a:off x="3310128" y="1572768"/>
+            <a:ext cx="2523744" cy="2148840"/>
           </a:xfrm>
           <a:prstGeom prst="rect">
             <a:avLst/>
@@ -12745,8 +12745,8 @@
         </p:nvSpPr>
         <p:spPr>
           <a:xfrm>
-            <a:off x="2624328" y="1572768"/>
-            <a:ext cx="41148" cy="2194560"/>
+            <a:off x="3310128" y="1572768"/>
+            <a:ext cx="41148" cy="2148840"/>
           </a:xfrm>
           <a:prstGeom prst="rect">
             <a:avLst/>
@@ -12757,169 +12757,9 @@
           <a:ln/>
         </p:spPr>
       </p:sp>
-      <p:sp>
-        <p:nvSpPr>
-          <p:cNvPr id="12" name="Text 10"/>
-          <p:cNvSpPr/>
-          <p:nvPr/>
-        </p:nvSpPr>
-        <p:spPr>
-          <a:xfrm>
-            <a:off x="2862072" y="1664208"/>
-            <a:ext cx="384048" cy="411480"/>
-          </a:xfrm>
-          <a:prstGeom prst="rect">
-            <a:avLst/>
-          </a:prstGeom>
-          <a:noFill/>
-          <a:ln/>
-        </p:spPr>
-        <p:txBody>
-          <a:bodyPr wrap="square" lIns="0" tIns="0" rIns="0" bIns="0" rtlCol="0" anchor="t"/>
-          <a:lstStyle/>
-          <a:p>
-            <a:pPr indent="0" marL="0">
-              <a:buNone/>
-            </a:pPr>
-            <a:r>
-              <a:rPr lang="en-US" sz="2000" b="1" dirty="0">
-                <a:solidFill>
-                  <a:srgbClr val="3843AF"/>
-                </a:solidFill>
-                <a:latin typeface="Courier New" pitchFamily="34" charset="0"/>
-                <a:ea typeface="Courier New" pitchFamily="34" charset="-122"/>
-                <a:cs typeface="Courier New" pitchFamily="34" charset="-120"/>
-              </a:rPr>
-              <a:t>2</a:t>
-            </a:r>
-            <a:endParaRPr lang="en-US" sz="2000" dirty="0"/>
-          </a:p>
-        </p:txBody>
-      </p:sp>
-      <p:sp>
-        <p:nvSpPr>
-          <p:cNvPr id="13" name="Text 11"/>
-          <p:cNvSpPr/>
-          <p:nvPr/>
-        </p:nvSpPr>
-        <p:spPr>
-          <a:xfrm>
-            <a:off x="3355848" y="1719072"/>
-            <a:ext cx="941832" cy="420624"/>
-          </a:xfrm>
-          <a:prstGeom prst="rect">
-            <a:avLst/>
-          </a:prstGeom>
-          <a:noFill/>
-          <a:ln/>
-        </p:spPr>
-        <p:txBody>
-          <a:bodyPr wrap="square" lIns="0" tIns="0" rIns="0" bIns="0" rtlCol="0" anchor="t"/>
-          <a:lstStyle/>
-          <a:p>
-            <a:pPr indent="0" marL="0">
-              <a:buNone/>
-            </a:pPr>
-            <a:r>
-              <a:rPr lang="en-US" sz="1200" b="1" dirty="0">
-                <a:solidFill>
-                  <a:srgbClr val="272E52"/>
-                </a:solidFill>
-                <a:latin typeface="Arial" pitchFamily="34" charset="0"/>
-                <a:ea typeface="Arial" pitchFamily="34" charset="-122"/>
-                <a:cs typeface="Arial" pitchFamily="34" charset="-120"/>
-              </a:rPr>
-              <a:t>Die Kursunterlagen</a:t>
-            </a:r>
-            <a:endParaRPr lang="en-US" sz="1200" dirty="0"/>
-          </a:p>
-        </p:txBody>
-      </p:sp>
-      <p:sp>
-        <p:nvSpPr>
-          <p:cNvPr id="14" name="Text 12"/>
-          <p:cNvSpPr/>
-          <p:nvPr/>
-        </p:nvSpPr>
-        <p:spPr>
-          <a:xfrm>
-            <a:off x="3355848" y="2185416"/>
-            <a:ext cx="941832" cy="1463040"/>
-          </a:xfrm>
-          <a:prstGeom prst="rect">
-            <a:avLst/>
-          </a:prstGeom>
-          <a:noFill/>
-          <a:ln/>
-        </p:spPr>
-        <p:txBody>
-          <a:bodyPr wrap="square" lIns="0" tIns="0" rIns="0" bIns="0" rtlCol="0" anchor="t"/>
-          <a:lstStyle/>
-          <a:p>
-            <a:pPr indent="0" marL="0">
-              <a:lnSpc>
-                <a:spcPct val="92000"/>
-              </a:lnSpc>
-              <a:buNone/>
-            </a:pPr>
-            <a:r>
-              <a:rPr lang="en-US" sz="1050" dirty="0">
-                <a:solidFill>
-                  <a:srgbClr val="434A63"/>
-                </a:solidFill>
-                <a:latin typeface="Arial" pitchFamily="34" charset="0"/>
-                <a:ea typeface="Arial" pitchFamily="34" charset="-122"/>
-                <a:cs typeface="Arial" pitchFamily="34" charset="-120"/>
-              </a:rPr>
-              <a:t>Alles im Detail: Erklärungen, Befehle, Übungen mit Lösungen, Glossar.</a:t>
-            </a:r>
-            <a:endParaRPr lang="en-US" sz="1050" dirty="0"/>
-          </a:p>
-        </p:txBody>
-      </p:sp>
-      <p:sp>
-        <p:nvSpPr>
-          <p:cNvPr id="15" name="Shape 13"/>
-          <p:cNvSpPr/>
-          <p:nvPr/>
-        </p:nvSpPr>
-        <p:spPr>
-          <a:xfrm>
-            <a:off x="4681728" y="1572768"/>
-            <a:ext cx="1837944" cy="2194560"/>
-          </a:xfrm>
-          <a:prstGeom prst="rect">
-            <a:avLst/>
-          </a:prstGeom>
-          <a:solidFill>
-            <a:srgbClr val="F5F6FC"/>
-          </a:solidFill>
-          <a:ln/>
-        </p:spPr>
-      </p:sp>
-      <p:sp>
-        <p:nvSpPr>
-          <p:cNvPr id="16" name="Shape 14"/>
-          <p:cNvSpPr/>
-          <p:nvPr/>
-        </p:nvSpPr>
-        <p:spPr>
-          <a:xfrm>
-            <a:off x="4681728" y="1572768"/>
-            <a:ext cx="41148" cy="2194560"/>
-          </a:xfrm>
-          <a:prstGeom prst="rect">
-            <a:avLst/>
-          </a:prstGeom>
-          <a:solidFill>
-            <a:srgbClr val="3843AF"/>
-          </a:solidFill>
-          <a:ln/>
-        </p:spPr>
-      </p:sp>
       <p:pic>
         <p:nvPicPr>
-          <p:cNvPr id="17" name="Image 0" descr="/Users/jacobmenge/Desktop/kurs-unterlagen/folien/assets/icons/cloudhelden.png">    </p:cNvPr>
+          <p:cNvPr id="12" name="Image 0" descr="/Users/jacobmenge/Desktop/kurs-unterlagen/folien/assets/icons/cloudhelden.png">    </p:cNvPr>
           <p:cNvPicPr>
             <a:picLocks noChangeAspect="1"/>
           </p:cNvPicPr>
@@ -12933,7 +12773,7 @@
         </p:blipFill>
         <p:spPr>
           <a:xfrm>
-            <a:off x="6099048" y="1700784"/>
+            <a:off x="5413248" y="1700784"/>
             <a:ext cx="274320" cy="274320"/>
           </a:xfrm>
           <a:prstGeom prst="rect">
@@ -12943,13 +12783,13 @@
       </p:pic>
       <p:sp>
         <p:nvSpPr>
-          <p:cNvPr id="18" name="Text 15"/>
-          <p:cNvSpPr/>
-          <p:nvPr/>
-        </p:nvSpPr>
-        <p:spPr>
-          <a:xfrm>
-            <a:off x="4919472" y="1664208"/>
+          <p:cNvPr id="13" name="Text 10"/>
+          <p:cNvSpPr/>
+          <p:nvPr/>
+        </p:nvSpPr>
+        <p:spPr>
+          <a:xfrm>
+            <a:off x="3547872" y="1664208"/>
             <a:ext cx="384048" cy="411480"/>
           </a:xfrm>
           <a:prstGeom prst="rect">
@@ -12974,7 +12814,7 @@
                 <a:ea typeface="Courier New" pitchFamily="34" charset="-122"/>
                 <a:cs typeface="Courier New" pitchFamily="34" charset="-120"/>
               </a:rPr>
-              <a:t>3</a:t>
+              <a:t>2</a:t>
             </a:r>
             <a:endParaRPr lang="en-US" sz="2000" dirty="0"/>
           </a:p>
@@ -12982,14 +12822,14 @@
       </p:sp>
       <p:sp>
         <p:nvSpPr>
-          <p:cNvPr id="19" name="Text 16"/>
-          <p:cNvSpPr/>
-          <p:nvPr/>
-        </p:nvSpPr>
-        <p:spPr>
-          <a:xfrm>
-            <a:off x="5413248" y="1719072"/>
-            <a:ext cx="941832" cy="420624"/>
+          <p:cNvPr id="14" name="Text 11"/>
+          <p:cNvSpPr/>
+          <p:nvPr/>
+        </p:nvSpPr>
+        <p:spPr>
+          <a:xfrm>
+            <a:off x="4041648" y="1719072"/>
+            <a:ext cx="1627632" cy="292608"/>
           </a:xfrm>
           <a:prstGeom prst="rect">
             <a:avLst/>
@@ -13005,7 +12845,7 @@
               <a:buNone/>
             </a:pPr>
             <a:r>
-              <a:rPr lang="en-US" sz="1200" b="1" dirty="0">
+              <a:rPr lang="en-US" sz="1250" b="1" dirty="0">
                 <a:solidFill>
                   <a:srgbClr val="272E52"/>
                 </a:solidFill>
@@ -13015,20 +12855,20 @@
               </a:rPr>
               <a:t>Die Akademie</a:t>
             </a:r>
-            <a:endParaRPr lang="en-US" sz="1200" dirty="0"/>
-          </a:p>
-        </p:txBody>
-      </p:sp>
-      <p:sp>
-        <p:nvSpPr>
-          <p:cNvPr id="20" name="Text 17"/>
-          <p:cNvSpPr/>
-          <p:nvPr/>
-        </p:nvSpPr>
-        <p:spPr>
-          <a:xfrm>
-            <a:off x="5413248" y="2185416"/>
-            <a:ext cx="941832" cy="1463040"/>
+            <a:endParaRPr lang="en-US" sz="1250" dirty="0"/>
+          </a:p>
+        </p:txBody>
+      </p:sp>
+      <p:sp>
+        <p:nvSpPr>
+          <p:cNvPr id="15" name="Text 12"/>
+          <p:cNvSpPr/>
+          <p:nvPr/>
+        </p:nvSpPr>
+        <p:spPr>
+          <a:xfrm>
+            <a:off x="4041648" y="2057400"/>
+            <a:ext cx="1627632" cy="1545336"/>
           </a:xfrm>
           <a:prstGeom prst="rect">
             <a:avLst/>
@@ -13047,7 +12887,7 @@
               <a:buNone/>
             </a:pPr>
             <a:r>
-              <a:rPr lang="en-US" sz="1050" dirty="0">
+              <a:rPr lang="en-US" sz="1100" dirty="0">
                 <a:solidFill>
                   <a:srgbClr val="434A63"/>
                 </a:solidFill>
@@ -13055,22 +12895,22 @@
                 <a:ea typeface="Arial" pitchFamily="34" charset="-122"/>
                 <a:cs typeface="Arial" pitchFamily="34" charset="-120"/>
               </a:rPr>
-              <a:t>Lernmodule zum Selbstlernen mit Quiz und Labs – plus alle Foliensätze und Probeklausuren.</a:t>
-            </a:r>
-            <a:endParaRPr lang="en-US" sz="1050" dirty="0"/>
-          </a:p>
-        </p:txBody>
-      </p:sp>
-      <p:sp>
-        <p:nvSpPr>
-          <p:cNvPr id="21" name="Shape 18"/>
-          <p:cNvSpPr/>
-          <p:nvPr/>
-        </p:nvSpPr>
-        <p:spPr>
-          <a:xfrm>
-            <a:off x="6739128" y="1572768"/>
-            <a:ext cx="1837944" cy="2194560"/>
+              <a:t>Eure zentrale Lernplattform: Lernmodule zum Selbstlernen mit Quiz und Labs – alles zum Vertiefen an einem Ort.</a:t>
+            </a:r>
+            <a:endParaRPr lang="en-US" sz="1100" dirty="0"/>
+          </a:p>
+        </p:txBody>
+      </p:sp>
+      <p:sp>
+        <p:nvSpPr>
+          <p:cNvPr id="16" name="Shape 13"/>
+          <p:cNvSpPr/>
+          <p:nvPr/>
+        </p:nvSpPr>
+        <p:spPr>
+          <a:xfrm>
+            <a:off x="6053328" y="1572768"/>
+            <a:ext cx="2523744" cy="2148840"/>
           </a:xfrm>
           <a:prstGeom prst="rect">
             <a:avLst/>
@@ -13083,14 +12923,14 @@
       </p:sp>
       <p:sp>
         <p:nvSpPr>
-          <p:cNvPr id="22" name="Shape 19"/>
-          <p:cNvSpPr/>
-          <p:nvPr/>
-        </p:nvSpPr>
-        <p:spPr>
-          <a:xfrm>
-            <a:off x="6739128" y="1572768"/>
-            <a:ext cx="41148" cy="2194560"/>
+          <p:cNvPr id="17" name="Shape 14"/>
+          <p:cNvSpPr/>
+          <p:nvPr/>
+        </p:nvSpPr>
+        <p:spPr>
+          <a:xfrm>
+            <a:off x="6053328" y="1572768"/>
+            <a:ext cx="41148" cy="2148840"/>
           </a:xfrm>
           <a:prstGeom prst="rect">
             <a:avLst/>
@@ -13103,7 +12943,7 @@
       </p:sp>
       <p:pic>
         <p:nvPicPr>
-          <p:cNvPr id="23" name="Image 1" descr="/Users/jacobmenge/Desktop/kurs-unterlagen/folien/assets/icons/pluralsight-F15B2A.png">    </p:cNvPr>
+          <p:cNvPr id="18" name="Image 1" descr="/Users/jacobmenge/Desktop/kurs-unterlagen/folien/assets/icons/pluralsight-F15B2A.png">    </p:cNvPr>
           <p:cNvPicPr>
             <a:picLocks noChangeAspect="1"/>
           </p:cNvPicPr>
@@ -13127,13 +12967,13 @@
       </p:pic>
       <p:sp>
         <p:nvSpPr>
-          <p:cNvPr id="24" name="Text 20"/>
-          <p:cNvSpPr/>
-          <p:nvPr/>
-        </p:nvSpPr>
-        <p:spPr>
-          <a:xfrm>
-            <a:off x="6976872" y="1664208"/>
+          <p:cNvPr id="19" name="Text 15"/>
+          <p:cNvSpPr/>
+          <p:nvPr/>
+        </p:nvSpPr>
+        <p:spPr>
+          <a:xfrm>
+            <a:off x="6291072" y="1664208"/>
             <a:ext cx="384048" cy="411480"/>
           </a:xfrm>
           <a:prstGeom prst="rect">
@@ -13158,7 +12998,7 @@
                 <a:ea typeface="Courier New" pitchFamily="34" charset="-122"/>
                 <a:cs typeface="Courier New" pitchFamily="34" charset="-120"/>
               </a:rPr>
-              <a:t>4</a:t>
+              <a:t>3</a:t>
             </a:r>
             <a:endParaRPr lang="en-US" sz="2000" dirty="0"/>
           </a:p>
@@ -13166,14 +13006,14 @@
       </p:sp>
       <p:sp>
         <p:nvSpPr>
-          <p:cNvPr id="25" name="Text 21"/>
-          <p:cNvSpPr/>
-          <p:nvPr/>
-        </p:nvSpPr>
-        <p:spPr>
-          <a:xfrm>
-            <a:off x="7470648" y="1719072"/>
-            <a:ext cx="941832" cy="420624"/>
+          <p:cNvPr id="20" name="Text 16"/>
+          <p:cNvSpPr/>
+          <p:nvPr/>
+        </p:nvSpPr>
+        <p:spPr>
+          <a:xfrm>
+            <a:off x="6784848" y="1719072"/>
+            <a:ext cx="1627632" cy="292608"/>
           </a:xfrm>
           <a:prstGeom prst="rect">
             <a:avLst/>
@@ -13189,7 +13029,7 @@
               <a:buNone/>
             </a:pPr>
             <a:r>
-              <a:rPr lang="en-US" sz="1200" b="1" dirty="0">
+              <a:rPr lang="en-US" sz="1250" b="1" dirty="0">
                 <a:solidFill>
                   <a:srgbClr val="272E52"/>
                 </a:solidFill>
@@ -13199,20 +13039,20 @@
               </a:rPr>
               <a:t>Pluralsight</a:t>
             </a:r>
-            <a:endParaRPr lang="en-US" sz="1200" dirty="0"/>
-          </a:p>
-        </p:txBody>
-      </p:sp>
-      <p:sp>
-        <p:nvSpPr>
-          <p:cNvPr id="26" name="Text 22"/>
-          <p:cNvSpPr/>
-          <p:nvPr/>
-        </p:nvSpPr>
-        <p:spPr>
-          <a:xfrm>
-            <a:off x="7470648" y="2185416"/>
-            <a:ext cx="941832" cy="1463040"/>
+            <a:endParaRPr lang="en-US" sz="1250" dirty="0"/>
+          </a:p>
+        </p:txBody>
+      </p:sp>
+      <p:sp>
+        <p:nvSpPr>
+          <p:cNvPr id="21" name="Text 17"/>
+          <p:cNvSpPr/>
+          <p:nvPr/>
+        </p:nvSpPr>
+        <p:spPr>
+          <a:xfrm>
+            <a:off x="6784848" y="2057400"/>
+            <a:ext cx="1627632" cy="1545336"/>
           </a:xfrm>
           <a:prstGeom prst="rect">
             <a:avLst/>
@@ -13231,7 +13071,7 @@
               <a:buNone/>
             </a:pPr>
             <a:r>
-              <a:rPr lang="en-US" sz="1050" dirty="0">
+              <a:rPr lang="en-US" sz="1100" dirty="0">
                 <a:solidFill>
                   <a:srgbClr val="434A63"/>
                 </a:solidFill>
@@ -13239,21 +13079,21 @@
                 <a:ea typeface="Arial" pitchFamily="34" charset="-122"/>
                 <a:cs typeface="Arial" pitchFamily="34" charset="-120"/>
               </a:rPr>
-              <a:t>Geführte Übungen in echten Cloud-Umgebungen.</a:t>
-            </a:r>
-            <a:endParaRPr lang="en-US" sz="1050" dirty="0"/>
-          </a:p>
-        </p:txBody>
-      </p:sp>
-      <p:sp>
-        <p:nvSpPr>
-          <p:cNvPr id="27" name="Shape 23"/>
-          <p:cNvSpPr/>
-          <p:nvPr/>
-        </p:nvSpPr>
-        <p:spPr>
-          <a:xfrm>
-            <a:off x="566928" y="4160520"/>
+              <a:t>Geführte Übungen in echten Cloud-Umgebungen. Den Zugang bekommt ihr gestellt.</a:t>
+            </a:r>
+            <a:endParaRPr lang="en-US" sz="1100" dirty="0"/>
+          </a:p>
+        </p:txBody>
+      </p:sp>
+      <p:sp>
+        <p:nvSpPr>
+          <p:cNvPr id="22" name="Shape 18"/>
+          <p:cNvSpPr/>
+          <p:nvPr/>
+        </p:nvSpPr>
+        <p:spPr>
+          <a:xfrm>
+            <a:off x="566928" y="4069080"/>
             <a:ext cx="32004" cy="256032"/>
           </a:xfrm>
           <a:prstGeom prst="rect">
@@ -13267,13 +13107,13 @@
       </p:sp>
       <p:sp>
         <p:nvSpPr>
-          <p:cNvPr id="28" name="Text 24"/>
-          <p:cNvSpPr/>
-          <p:nvPr/>
-        </p:nvSpPr>
-        <p:spPr>
-          <a:xfrm>
-            <a:off x="749808" y="4114800"/>
+          <p:cNvPr id="23" name="Text 19"/>
+          <p:cNvSpPr/>
+          <p:nvPr/>
+        </p:nvSpPr>
+        <p:spPr>
+          <a:xfrm>
+            <a:off x="749808" y="4023360"/>
             <a:ext cx="7827264" cy="402336"/>
           </a:xfrm>
           <a:prstGeom prst="rect">
@@ -13298,7 +13138,7 @@
                 <a:ea typeface="Arial" pitchFamily="34" charset="-122"/>
                 <a:cs typeface="Arial" pitchFamily="34" charset="-120"/>
               </a:rPr>
-              <a:t>Den Link zu den Kursunterlagen bekommt ihr gleich im Anschluss.</a:t>
+              <a:t>Alles läuft über akademie.cloudhelden.org – dort ist auch der Meeting-Link.</a:t>
             </a:r>
             <a:endParaRPr lang="en-US" sz="1200" dirty="0"/>
           </a:p>
@@ -13306,7 +13146,7 @@
       </p:sp>
       <p:sp>
         <p:nvSpPr>
-          <p:cNvPr id="29" name="Shape 25"/>
+          <p:cNvPr id="24" name="Shape 20"/>
           <p:cNvSpPr/>
           <p:nvPr/>
         </p:nvSpPr>
@@ -13329,7 +13169,7 @@
       </p:sp>
       <p:sp>
         <p:nvSpPr>
-          <p:cNvPr id="30" name="Text 26"/>
+          <p:cNvPr id="25" name="Text 21"/>
           <p:cNvSpPr/>
           <p:nvPr/>
         </p:nvSpPr>
@@ -13368,7 +13208,7 @@
       </p:sp>
       <p:sp>
         <p:nvSpPr>
-          <p:cNvPr id="31" name="Text 27"/>
+          <p:cNvPr id="26" name="Text 22"/>
           <p:cNvSpPr/>
           <p:nvPr/>
         </p:nvSpPr>
@@ -14439,7 +14279,7 @@
                 <a:ea typeface="Arial" pitchFamily="34" charset="-122"/>
                 <a:cs typeface="Arial" pitchFamily="34" charset="-120"/>
               </a:rPr>
-              <a:t>Wer mag, schaut vorher schon in die Kursunterlagen – Pflicht ist das nicht.</a:t>
+              <a:t>Wer mag, schaut vorher in die Lernmodule in der Akademie – Pflicht ist das nicht.</a:t>
             </a:r>
             <a:endParaRPr lang="en-US" sz="1300" dirty="0"/>
           </a:p>

</xml_diff>

<commit_message>
folien: prüfungstermin und pünktlichkeit aus dem dozenten-briefing ergänzt
</commit_message>
<xml_diff>
--- a/folien/dist/00-orientierung.pptx
+++ b/folien/dist/00-orientierung.pptx
@@ -3139,7 +3139,7 @@
                 <a:ea typeface="Arial" pitchFamily="34" charset="-122"/>
                 <a:cs typeface="Arial" pitchFamily="34" charset="-120"/>
               </a:rPr>
-              <a:t>Orientierungsabend</a:t>
+              <a:t>Orientierungsabend · 24. August 2026</a:t>
             </a:r>
             <a:endParaRPr lang="en-US" sz="1100" dirty="0"/>
           </a:p>
@@ -5753,7 +5753,7 @@
                 <a:ea typeface="Arial" pitchFamily="34" charset="-122"/>
                 <a:cs typeface="Arial" pitchFamily="34" charset="-120"/>
               </a:rPr>
-              <a:t>schriftlich,</a:t>
+              <a:t>18. März 2027</a:t>
             </a:r>
             <a:endParaRPr lang="en-US" sz="1100" dirty="0"/>
           </a:p>
@@ -5770,7 +5770,7 @@
                 <a:ea typeface="Arial" pitchFamily="34" charset="-122"/>
                 <a:cs typeface="Arial" pitchFamily="34" charset="-120"/>
               </a:rPr>
-              <a:t>danach mündlich</a:t>
+              <a:t>schriftlich</a:t>
             </a:r>
             <a:endParaRPr lang="en-US" sz="1100" dirty="0"/>
           </a:p>
@@ -8247,7 +8247,7 @@
                 <a:ea typeface="Arial" pitchFamily="34" charset="-122"/>
                 <a:cs typeface="Arial" pitchFamily="34" charset="-120"/>
               </a:rPr>
-              <a:t>Keine Wissensabfrage, sondern ein Fall aus dem Betrieb, den ihr durchdenkt und löst.</a:t>
+              <a:t>Am 18. März 2027. Keine Wissensabfrage, sondern ein Fall aus dem Betrieb, den ihr durchdenkt und löst.</a:t>
             </a:r>
             <a:endParaRPr lang="en-US" sz="1300" dirty="0"/>
           </a:p>
@@ -10442,7 +10442,7 @@
                 <a:ea typeface="Arial" pitchFamily="34" charset="-122"/>
                 <a:cs typeface="Arial" pitchFamily="34" charset="-120"/>
               </a:rPr>
-              <a:t>Der Unterricht wird nicht aufgezeichnet – seid also möglichst dabei.</a:t>
+              <a:t>Der Unterricht wird nicht aufgezeichnet – kommt pünktlich und seid möglichst immer dabei.</a:t>
             </a:r>
             <a:endParaRPr lang="en-US" sz="1400" dirty="0"/>
           </a:p>

</xml_diff>

<commit_message>
folien: kennzahlen zentriert, vorschau-ausrichtung korrigiert
</commit_message>
<xml_diff>
--- a/folien/dist/00-orientierung.pptx
+++ b/folien/dist/00-orientierung.pptx
@@ -9501,7 +9501,7 @@
           <a:bodyPr wrap="square" lIns="0" tIns="0" rIns="0" bIns="0" rtlCol="0" anchor="t"/>
           <a:lstStyle/>
           <a:p>
-            <a:pPr algn="l" indent="0" marL="0">
+            <a:pPr algn="ctr" indent="0" marL="0">
               <a:buNone/>
             </a:pPr>
             <a:r>
@@ -9540,7 +9540,7 @@
           <a:bodyPr wrap="square" lIns="0" tIns="0" rIns="0" bIns="0" rtlCol="0" anchor="t"/>
           <a:lstStyle/>
           <a:p>
-            <a:pPr algn="l" indent="0" marL="0">
+            <a:pPr algn="ctr" indent="0" marL="0">
               <a:buNone/>
             </a:pPr>
             <a:r>
@@ -9557,7 +9557,7 @@
             <a:endParaRPr lang="en-US" sz="1150" dirty="0"/>
           </a:p>
           <a:p>
-            <a:pPr algn="l" indent="0" marL="0">
+            <a:pPr algn="ctr" indent="0" marL="0">
               <a:buNone/>
             </a:pPr>
             <a:r>
@@ -9596,7 +9596,7 @@
           <a:bodyPr wrap="square" lIns="0" tIns="0" rIns="0" bIns="0" rtlCol="0" anchor="t"/>
           <a:lstStyle/>
           <a:p>
-            <a:pPr algn="l" indent="0" marL="0">
+            <a:pPr algn="ctr" indent="0" marL="0">
               <a:buNone/>
             </a:pPr>
             <a:r>
@@ -9635,7 +9635,7 @@
           <a:bodyPr wrap="square" lIns="0" tIns="0" rIns="0" bIns="0" rtlCol="0" anchor="t"/>
           <a:lstStyle/>
           <a:p>
-            <a:pPr algn="l" indent="0" marL="0">
+            <a:pPr algn="ctr" indent="0" marL="0">
               <a:buNone/>
             </a:pPr>
             <a:r>
@@ -9652,7 +9652,7 @@
             <a:endParaRPr lang="en-US" sz="1150" dirty="0"/>
           </a:p>
           <a:p>
-            <a:pPr algn="l" indent="0" marL="0">
+            <a:pPr algn="ctr" indent="0" marL="0">
               <a:buNone/>
             </a:pPr>
             <a:r>
@@ -9691,7 +9691,7 @@
           <a:bodyPr wrap="square" lIns="0" tIns="0" rIns="0" bIns="0" rtlCol="0" anchor="t"/>
           <a:lstStyle/>
           <a:p>
-            <a:pPr algn="l" indent="0" marL="0">
+            <a:pPr algn="ctr" indent="0" marL="0">
               <a:buNone/>
             </a:pPr>
             <a:r>
@@ -9730,7 +9730,7 @@
           <a:bodyPr wrap="square" lIns="0" tIns="0" rIns="0" bIns="0" rtlCol="0" anchor="t"/>
           <a:lstStyle/>
           <a:p>
-            <a:pPr algn="l" indent="0" marL="0">
+            <a:pPr algn="ctr" indent="0" marL="0">
               <a:buNone/>
             </a:pPr>
             <a:r>
@@ -9747,7 +9747,7 @@
             <a:endParaRPr lang="en-US" sz="1150" dirty="0"/>
           </a:p>
           <a:p>
-            <a:pPr algn="l" indent="0" marL="0">
+            <a:pPr algn="ctr" indent="0" marL="0">
               <a:buNone/>
             </a:pPr>
             <a:r>
@@ -17699,7 +17699,7 @@
           <a:bodyPr wrap="square" lIns="0" tIns="0" rIns="0" bIns="0" rtlCol="0" anchor="t"/>
           <a:lstStyle/>
           <a:p>
-            <a:pPr algn="l" indent="0" marL="0">
+            <a:pPr algn="ctr" indent="0" marL="0">
               <a:buNone/>
             </a:pPr>
             <a:r>
@@ -17738,7 +17738,7 @@
           <a:bodyPr wrap="square" lIns="0" tIns="0" rIns="0" bIns="0" rtlCol="0" anchor="t"/>
           <a:lstStyle/>
           <a:p>
-            <a:pPr algn="l" indent="0" marL="0">
+            <a:pPr algn="ctr" indent="0" marL="0">
               <a:buNone/>
             </a:pPr>
             <a:r>
@@ -17755,7 +17755,7 @@
             <a:endParaRPr lang="en-US" sz="1150" dirty="0"/>
           </a:p>
           <a:p>
-            <a:pPr algn="l" indent="0" marL="0">
+            <a:pPr algn="ctr" indent="0" marL="0">
               <a:buNone/>
             </a:pPr>
             <a:r>
@@ -17794,7 +17794,7 @@
           <a:bodyPr wrap="square" lIns="0" tIns="0" rIns="0" bIns="0" rtlCol="0" anchor="t"/>
           <a:lstStyle/>
           <a:p>
-            <a:pPr algn="l" indent="0" marL="0">
+            <a:pPr algn="ctr" indent="0" marL="0">
               <a:buNone/>
             </a:pPr>
             <a:r>
@@ -17833,7 +17833,7 @@
           <a:bodyPr wrap="square" lIns="0" tIns="0" rIns="0" bIns="0" rtlCol="0" anchor="t"/>
           <a:lstStyle/>
           <a:p>
-            <a:pPr algn="l" indent="0" marL="0">
+            <a:pPr algn="ctr" indent="0" marL="0">
               <a:buNone/>
             </a:pPr>
             <a:r>
@@ -17850,7 +17850,7 @@
             <a:endParaRPr lang="en-US" sz="1150" dirty="0"/>
           </a:p>
           <a:p>
-            <a:pPr algn="l" indent="0" marL="0">
+            <a:pPr algn="ctr" indent="0" marL="0">
               <a:buNone/>
             </a:pPr>
             <a:r>
@@ -17889,7 +17889,7 @@
           <a:bodyPr wrap="square" lIns="0" tIns="0" rIns="0" bIns="0" rtlCol="0" anchor="t"/>
           <a:lstStyle/>
           <a:p>
-            <a:pPr algn="l" indent="0" marL="0">
+            <a:pPr algn="ctr" indent="0" marL="0">
               <a:buNone/>
             </a:pPr>
             <a:r>
@@ -17928,7 +17928,7 @@
           <a:bodyPr wrap="square" lIns="0" tIns="0" rIns="0" bIns="0" rtlCol="0" anchor="t"/>
           <a:lstStyle/>
           <a:p>
-            <a:pPr algn="l" indent="0" marL="0">
+            <a:pPr algn="ctr" indent="0" marL="0">
               <a:buNone/>
             </a:pPr>
             <a:r>
@@ -17945,7 +17945,7 @@
             <a:endParaRPr lang="en-US" sz="1150" dirty="0"/>
           </a:p>
           <a:p>
-            <a:pPr algn="l" indent="0" marL="0">
+            <a:pPr algn="ctr" indent="0" marL="0">
               <a:buNone/>
             </a:pPr>
             <a:r>

</xml_diff>

<commit_message>
folien: bernstein-akzent abgedunkelt für ausreichenden kontrast
</commit_message>
<xml_diff>
--- a/folien/dist/00-orientierung.pptx
+++ b/folien/dist/00-orientierung.pptx
@@ -3779,7 +3779,7 @@
             <a:avLst/>
           </a:prstGeom>
           <a:solidFill>
-            <a:srgbClr val="A96D12"/>
+            <a:srgbClr val="9A6310"/>
           </a:solidFill>
           <a:ln/>
         </p:spPr>
@@ -3811,7 +3811,7 @@
             <a:r>
               <a:rPr lang="en-US" sz="2000" b="1" dirty="0">
                 <a:solidFill>
-                  <a:srgbClr val="A96D12"/>
+                  <a:srgbClr val="9A6310"/>
                 </a:solidFill>
                 <a:latin typeface="Courier New" pitchFamily="34" charset="0"/>
                 <a:ea typeface="Courier New" pitchFamily="34" charset="-122"/>
@@ -4626,7 +4626,7 @@
             <a:avLst/>
           </a:prstGeom>
           <a:solidFill>
-            <a:srgbClr val="A96D12"/>
+            <a:srgbClr val="9A6310"/>
           </a:solidFill>
           <a:ln/>
         </p:spPr>
@@ -4658,7 +4658,7 @@
             <a:r>
               <a:rPr lang="en-US" sz="2000" b="1" dirty="0">
                 <a:solidFill>
-                  <a:srgbClr val="A96D12"/>
+                  <a:srgbClr val="9A6310"/>
                 </a:solidFill>
                 <a:latin typeface="Courier New" pitchFamily="34" charset="0"/>
                 <a:ea typeface="Courier New" pitchFamily="34" charset="-122"/>

</xml_diff>

<commit_message>
folien: kartenlayout robuster (titelumbruch, icon-freiraum), schaubilder nachjustiert, aussagen zur ausbildung praezisiert
</commit_message>
<xml_diff>
--- a/folien/dist/00-orientierung.pptx
+++ b/folien/dist/00-orientierung.pptx
@@ -3832,7 +3832,7 @@
         <p:spPr>
           <a:xfrm>
             <a:off x="6784848" y="2121408"/>
-            <a:ext cx="1627632" cy="292608"/>
+            <a:ext cx="1627632" cy="440182"/>
           </a:xfrm>
           <a:prstGeom prst="rect">
             <a:avLst/>
@@ -3870,8 +3870,8 @@
         </p:nvSpPr>
         <p:spPr>
           <a:xfrm>
-            <a:off x="6784848" y="2459736"/>
-            <a:ext cx="1627632" cy="1408176"/>
+            <a:off x="6784848" y="2607310"/>
+            <a:ext cx="1627632" cy="1260602"/>
           </a:xfrm>
           <a:prstGeom prst="rect">
             <a:avLst/>
@@ -4425,7 +4425,7 @@
                 <a:ea typeface="Arial" pitchFamily="34" charset="-122"/>
                 <a:cs typeface="Arial" pitchFamily="34" charset="-120"/>
               </a:rPr>
-              <a:t>Netzwerke, Virtualisierung, Container, Architekturen, Speicher, Ressourcen und Lizenzen. Wie entsteht eine Infrastruktur?</a:t>
+              <a:t>Netzwerke, Virtualisierung, Container, Speicher, Ressourcen, Lizenzen – wie entsteht eine Infrastruktur?</a:t>
             </a:r>
             <a:endParaRPr lang="en-US" sz="1100" dirty="0"/>
           </a:p>
@@ -7655,7 +7655,7 @@
         <p:spPr>
           <a:xfrm>
             <a:off x="804672" y="2121408"/>
-            <a:ext cx="3493008" cy="274320"/>
+            <a:ext cx="3090672" cy="274320"/>
           </a:xfrm>
           <a:prstGeom prst="rect">
             <a:avLst/>
@@ -10641,7 +10641,7 @@
         <p:spPr>
           <a:xfrm>
             <a:off x="804672" y="4059936"/>
-            <a:ext cx="7607808" cy="192024"/>
+            <a:ext cx="7260336" cy="192024"/>
           </a:xfrm>
           <a:prstGeom prst="rect">
             <a:avLst/>
@@ -12829,7 +12829,7 @@
         <p:spPr>
           <a:xfrm>
             <a:off x="4041648" y="1719072"/>
-            <a:ext cx="1627632" cy="292608"/>
+            <a:ext cx="1225296" cy="292608"/>
           </a:xfrm>
           <a:prstGeom prst="rect">
             <a:avLst/>
@@ -13013,7 +13013,7 @@
         <p:spPr>
           <a:xfrm>
             <a:off x="6784848" y="1719072"/>
-            <a:ext cx="1627632" cy="292608"/>
+            <a:ext cx="1225296" cy="292608"/>
           </a:xfrm>
           <a:prstGeom prst="rect">
             <a:avLst/>

</xml_diff>